<commit_message>
Fix the fitted_models gitignore, which tracked nothing it claimed to
`demo/synthetic/fitted_models/**` ignores the run DIRECTORIES, and git never
descends into an ignored directory, so the `!.../<run>/*.csv` exceptions below
it were never evaluated. The block looked like it tracked the
realistic_baseline_2ch CSVs; `git ls-files` on that path returned nothing.

Rewritten with the working idiom -- unignore the directory, re-ignore its
contents, then admit the wanted files -- and extended to the three r90 arms.
The `models/` subdirectories (~380MB of .nc posteriors) stay ignored.

Also carries the corrections from the 50-draw run: CLAUDE.md's Channel-2
"unexplained alpha_m miss" is retracted as a 10-seed artifact, and the max_lag
suspect is ruled out arithmetically (99.999996% of adstock mass sits in lags
0-8 at alpha=0.15).

Co-Authored-By: Claude Opus 5 <noreply@anthropic.com>
</commit_message>
<xml_diff>
--- a/demo/synthetic/arf_section1_deck.pptx
+++ b/demo/synthetic/arf_section1_deck.pptx
@@ -6,9 +6,14 @@
   </p:sldMasterIdLst>
   <p:sldIdLst>
     <p:sldId id="256" r:id="rId7"/>
-    <p:sldId id="257" r:id="rId9"/>
-    <p:sldId id="258" r:id="rId10"/>
-    <p:sldId id="259" r:id="rId11"/>
+    <p:sldId id="257" r:id="rId8"/>
+    <p:sldId id="258" r:id="rId9"/>
+    <p:sldId id="259" r:id="rId10"/>
+    <p:sldId id="260" r:id="rId11"/>
+    <p:sldId id="261" r:id="rId12"/>
+    <p:sldId id="262" r:id="rId13"/>
+    <p:sldId id="263" r:id="rId14"/>
+    <p:sldId id="264" r:id="rId15"/>
   </p:sldIdLst>
   <p:sldSz cx="12191695" cy="6858000" type="screen4x3"/>
   <p:notesSz cx="6858000" cy="9144000"/>
@@ -108,735 +113,6 @@
     </a:lvl9pPr>
   </p:defaultTextStyle>
 </p:presentation>
-</file>
-
-<file path=ppt/notesMasters/notesMaster1.xml><?xml version="1.0" encoding="utf-8"?>
-<p:notesMaster xmlns:a="http://schemas.openxmlformats.org/drawingml/2006/main" xmlns:p="http://schemas.openxmlformats.org/presentationml/2006/main" xmlns:r="http://schemas.openxmlformats.org/officeDocument/2006/relationships">
-  <p:cSld>
-    <p:bg>
-      <p:bgRef idx="1001">
-        <a:schemeClr val="bg1"/>
-      </p:bgRef>
-    </p:bg>
-    <p:spTree>
-      <p:nvGrpSpPr>
-        <p:cNvPr id="1" name=""/>
-        <p:cNvGrpSpPr/>
-        <p:nvPr/>
-      </p:nvGrpSpPr>
-      <p:grpSpPr>
-        <a:xfrm>
-          <a:off x="0" y="0"/>
-          <a:ext cx="0" cy="0"/>
-          <a:chOff x="0" y="0"/>
-          <a:chExt cx="0" cy="0"/>
-        </a:xfrm>
-      </p:grpSpPr>
-      <p:sp>
-        <p:nvSpPr>
-          <p:cNvPr id="2" name="Header Placeholder 1"/>
-          <p:cNvSpPr>
-            <a:spLocks noGrp="1"/>
-          </p:cNvSpPr>
-          <p:nvPr>
-            <p:ph type="hdr" sz="quarter"/>
-          </p:nvPr>
-        </p:nvSpPr>
-        <p:spPr>
-          <a:xfrm>
-            <a:off x="0" y="0"/>
-            <a:ext cx="2971800" cy="457200"/>
-          </a:xfrm>
-          <a:prstGeom prst="rect">
-            <a:avLst/>
-          </a:prstGeom>
-        </p:spPr>
-        <p:txBody>
-          <a:bodyPr vert="horz" lIns="91440" tIns="45720" rIns="91440" bIns="45720" rtlCol="0"/>
-          <a:lstStyle>
-            <a:lvl1pPr algn="l">
-              <a:defRPr sz="1200"/>
-            </a:lvl1pPr>
-          </a:lstStyle>
-          <a:p>
-            <a:endParaRPr lang="en-US"/>
-          </a:p>
-        </p:txBody>
-      </p:sp>
-      <p:sp>
-        <p:nvSpPr>
-          <p:cNvPr id="3" name="Date Placeholder 2"/>
-          <p:cNvSpPr>
-            <a:spLocks noGrp="1"/>
-          </p:cNvSpPr>
-          <p:nvPr>
-            <p:ph type="dt" idx="1"/>
-          </p:nvPr>
-        </p:nvSpPr>
-        <p:spPr>
-          <a:xfrm>
-            <a:off x="3884613" y="0"/>
-            <a:ext cx="2971800" cy="457200"/>
-          </a:xfrm>
-          <a:prstGeom prst="rect">
-            <a:avLst/>
-          </a:prstGeom>
-        </p:spPr>
-        <p:txBody>
-          <a:bodyPr vert="horz" lIns="91440" tIns="45720" rIns="91440" bIns="45720" rtlCol="0"/>
-          <a:lstStyle>
-            <a:lvl1pPr algn="r">
-              <a:defRPr sz="1200"/>
-            </a:lvl1pPr>
-          </a:lstStyle>
-          <a:p>
-            <a:fld id="{0F89C1C7-3DCD-1040-A9CF-14679D8B5DDD}" type="datetimeFigureOut">
-              <a:rPr lang="en-US" smtClean="0"/>
-              <a:t>10/17/16</a:t>
-            </a:fld>
-            <a:endParaRPr lang="en-US"/>
-          </a:p>
-        </p:txBody>
-      </p:sp>
-      <p:sp>
-        <p:nvSpPr>
-          <p:cNvPr id="4" name="Slide Image Placeholder 3"/>
-          <p:cNvSpPr>
-            <a:spLocks noGrp="1" noRot="1" noChangeAspect="1"/>
-          </p:cNvSpPr>
-          <p:nvPr>
-            <p:ph type="sldImg" idx="2"/>
-          </p:nvPr>
-        </p:nvSpPr>
-        <p:spPr>
-          <a:xfrm>
-            <a:off x="1143000" y="685800"/>
-            <a:ext cx="4572000" cy="3429000"/>
-          </a:xfrm>
-          <a:prstGeom prst="rect">
-            <a:avLst/>
-          </a:prstGeom>
-          <a:noFill/>
-          <a:ln w="12700">
-            <a:solidFill>
-              <a:prstClr val="black"/>
-            </a:solidFill>
-          </a:ln>
-        </p:spPr>
-        <p:txBody>
-          <a:bodyPr vert="horz" lIns="91440" tIns="45720" rIns="91440" bIns="45720" rtlCol="0" anchor="ctr"/>
-          <a:lstStyle/>
-          <a:p>
-            <a:endParaRPr lang="en-US"/>
-          </a:p>
-        </p:txBody>
-      </p:sp>
-      <p:sp>
-        <p:nvSpPr>
-          <p:cNvPr id="5" name="Notes Placeholder 4"/>
-          <p:cNvSpPr>
-            <a:spLocks noGrp="1"/>
-          </p:cNvSpPr>
-          <p:nvPr>
-            <p:ph type="body" sz="quarter" idx="3"/>
-          </p:nvPr>
-        </p:nvSpPr>
-        <p:spPr>
-          <a:xfrm>
-            <a:off x="685800" y="4343400"/>
-            <a:ext cx="5486400" cy="4114800"/>
-          </a:xfrm>
-          <a:prstGeom prst="rect">
-            <a:avLst/>
-          </a:prstGeom>
-        </p:spPr>
-        <p:txBody>
-          <a:bodyPr vert="horz" lIns="91440" tIns="45720" rIns="91440" bIns="45720" rtlCol="0"/>
-          <a:lstStyle/>
-          <a:p>
-            <a:pPr lvl="0"/>
-            <a:r>
-              <a:rPr lang="en-US" smtClean="0"/>
-              <a:t>Click to edit Master text styles</a:t>
-            </a:r>
-          </a:p>
-          <a:p>
-            <a:pPr lvl="1"/>
-            <a:r>
-              <a:rPr lang="en-US" smtClean="0"/>
-              <a:t>Second level</a:t>
-            </a:r>
-          </a:p>
-          <a:p>
-            <a:pPr lvl="2"/>
-            <a:r>
-              <a:rPr lang="en-US" smtClean="0"/>
-              <a:t>Third level</a:t>
-            </a:r>
-          </a:p>
-          <a:p>
-            <a:pPr lvl="3"/>
-            <a:r>
-              <a:rPr lang="en-US" smtClean="0"/>
-              <a:t>Fourth level</a:t>
-            </a:r>
-          </a:p>
-          <a:p>
-            <a:pPr lvl="4"/>
-            <a:r>
-              <a:rPr lang="en-US" smtClean="0"/>
-              <a:t>Fifth level</a:t>
-            </a:r>
-            <a:endParaRPr lang="en-US"/>
-          </a:p>
-        </p:txBody>
-      </p:sp>
-      <p:sp>
-        <p:nvSpPr>
-          <p:cNvPr id="6" name="Footer Placeholder 5"/>
-          <p:cNvSpPr>
-            <a:spLocks noGrp="1"/>
-          </p:cNvSpPr>
-          <p:nvPr>
-            <p:ph type="ftr" sz="quarter" idx="4"/>
-          </p:nvPr>
-        </p:nvSpPr>
-        <p:spPr>
-          <a:xfrm>
-            <a:off x="0" y="8685213"/>
-            <a:ext cx="2971800" cy="457200"/>
-          </a:xfrm>
-          <a:prstGeom prst="rect">
-            <a:avLst/>
-          </a:prstGeom>
-        </p:spPr>
-        <p:txBody>
-          <a:bodyPr vert="horz" lIns="91440" tIns="45720" rIns="91440" bIns="45720" rtlCol="0" anchor="b"/>
-          <a:lstStyle>
-            <a:lvl1pPr algn="l">
-              <a:defRPr sz="1200"/>
-            </a:lvl1pPr>
-          </a:lstStyle>
-          <a:p>
-            <a:endParaRPr lang="en-US"/>
-          </a:p>
-        </p:txBody>
-      </p:sp>
-      <p:sp>
-        <p:nvSpPr>
-          <p:cNvPr id="7" name="Slide Number Placeholder 6"/>
-          <p:cNvSpPr>
-            <a:spLocks noGrp="1"/>
-          </p:cNvSpPr>
-          <p:nvPr>
-            <p:ph type="sldNum" sz="quarter" idx="5"/>
-          </p:nvPr>
-        </p:nvSpPr>
-        <p:spPr>
-          <a:xfrm>
-            <a:off x="3884613" y="8685213"/>
-            <a:ext cx="2971800" cy="457200"/>
-          </a:xfrm>
-          <a:prstGeom prst="rect">
-            <a:avLst/>
-          </a:prstGeom>
-        </p:spPr>
-        <p:txBody>
-          <a:bodyPr vert="horz" lIns="91440" tIns="45720" rIns="91440" bIns="45720" rtlCol="0" anchor="b"/>
-          <a:lstStyle>
-            <a:lvl1pPr algn="r">
-              <a:defRPr sz="1200"/>
-            </a:lvl1pPr>
-          </a:lstStyle>
-          <a:p>
-            <a:fld id="{BB5E49A5-4136-284D-997B-48E1D791AD67}" type="slidenum">
-              <a:rPr lang="en-US" smtClean="0"/>
-              <a:t>‹#›</a:t>
-            </a:fld>
-            <a:endParaRPr lang="en-US"/>
-          </a:p>
-        </p:txBody>
-      </p:sp>
-    </p:spTree>
-    <p:extLst>
-      <p:ext uri="{BB962C8B-B14F-4D97-AF65-F5344CB8AC3E}">
-        <p14:creationId xmlns:p14="http://schemas.microsoft.com/office/powerpoint/2010/main" val="2623252185"/>
-      </p:ext>
-    </p:extLst>
-  </p:cSld>
-  <p:clrMap bg1="lt1" tx1="dk1" bg2="lt2" tx2="dk2" accent1="accent1" accent2="accent2" accent3="accent3" accent4="accent4" accent5="accent5" accent6="accent6" hlink="hlink" folHlink="folHlink"/>
-  <p:notesStyle>
-    <a:lvl1pPr marL="0" algn="l" defTabSz="457200" rtl="0" eaLnBrk="1" latinLnBrk="0" hangingPunct="1">
-      <a:defRPr sz="1200" kern="1200">
-        <a:solidFill>
-          <a:schemeClr val="tx1"/>
-        </a:solidFill>
-        <a:latin typeface="+mn-lt"/>
-        <a:ea typeface="+mn-ea"/>
-        <a:cs typeface="+mn-cs"/>
-      </a:defRPr>
-    </a:lvl1pPr>
-    <a:lvl2pPr marL="457200" algn="l" defTabSz="457200" rtl="0" eaLnBrk="1" latinLnBrk="0" hangingPunct="1">
-      <a:defRPr sz="1200" kern="1200">
-        <a:solidFill>
-          <a:schemeClr val="tx1"/>
-        </a:solidFill>
-        <a:latin typeface="+mn-lt"/>
-        <a:ea typeface="+mn-ea"/>
-        <a:cs typeface="+mn-cs"/>
-      </a:defRPr>
-    </a:lvl2pPr>
-    <a:lvl3pPr marL="914400" algn="l" defTabSz="457200" rtl="0" eaLnBrk="1" latinLnBrk="0" hangingPunct="1">
-      <a:defRPr sz="1200" kern="1200">
-        <a:solidFill>
-          <a:schemeClr val="tx1"/>
-        </a:solidFill>
-        <a:latin typeface="+mn-lt"/>
-        <a:ea typeface="+mn-ea"/>
-        <a:cs typeface="+mn-cs"/>
-      </a:defRPr>
-    </a:lvl3pPr>
-    <a:lvl4pPr marL="1371600" algn="l" defTabSz="457200" rtl="0" eaLnBrk="1" latinLnBrk="0" hangingPunct="1">
-      <a:defRPr sz="1200" kern="1200">
-        <a:solidFill>
-          <a:schemeClr val="tx1"/>
-        </a:solidFill>
-        <a:latin typeface="+mn-lt"/>
-        <a:ea typeface="+mn-ea"/>
-        <a:cs typeface="+mn-cs"/>
-      </a:defRPr>
-    </a:lvl4pPr>
-    <a:lvl5pPr marL="1828800" algn="l" defTabSz="457200" rtl="0" eaLnBrk="1" latinLnBrk="0" hangingPunct="1">
-      <a:defRPr sz="1200" kern="1200">
-        <a:solidFill>
-          <a:schemeClr val="tx1"/>
-        </a:solidFill>
-        <a:latin typeface="+mn-lt"/>
-        <a:ea typeface="+mn-ea"/>
-        <a:cs typeface="+mn-cs"/>
-      </a:defRPr>
-    </a:lvl5pPr>
-    <a:lvl6pPr marL="2286000" algn="l" defTabSz="457200" rtl="0" eaLnBrk="1" latinLnBrk="0" hangingPunct="1">
-      <a:defRPr sz="1200" kern="1200">
-        <a:solidFill>
-          <a:schemeClr val="tx1"/>
-        </a:solidFill>
-        <a:latin typeface="+mn-lt"/>
-        <a:ea typeface="+mn-ea"/>
-        <a:cs typeface="+mn-cs"/>
-      </a:defRPr>
-    </a:lvl6pPr>
-    <a:lvl7pPr marL="2743200" algn="l" defTabSz="457200" rtl="0" eaLnBrk="1" latinLnBrk="0" hangingPunct="1">
-      <a:defRPr sz="1200" kern="1200">
-        <a:solidFill>
-          <a:schemeClr val="tx1"/>
-        </a:solidFill>
-        <a:latin typeface="+mn-lt"/>
-        <a:ea typeface="+mn-ea"/>
-        <a:cs typeface="+mn-cs"/>
-      </a:defRPr>
-    </a:lvl7pPr>
-    <a:lvl8pPr marL="3200400" algn="l" defTabSz="457200" rtl="0" eaLnBrk="1" latinLnBrk="0" hangingPunct="1">
-      <a:defRPr sz="1200" kern="1200">
-        <a:solidFill>
-          <a:schemeClr val="tx1"/>
-        </a:solidFill>
-        <a:latin typeface="+mn-lt"/>
-        <a:ea typeface="+mn-ea"/>
-        <a:cs typeface="+mn-cs"/>
-      </a:defRPr>
-    </a:lvl8pPr>
-    <a:lvl9pPr marL="3657600" algn="l" defTabSz="457200" rtl="0" eaLnBrk="1" latinLnBrk="0" hangingPunct="1">
-      <a:defRPr sz="1200" kern="1200">
-        <a:solidFill>
-          <a:schemeClr val="tx1"/>
-        </a:solidFill>
-        <a:latin typeface="+mn-lt"/>
-        <a:ea typeface="+mn-ea"/>
-        <a:cs typeface="+mn-cs"/>
-      </a:defRPr>
-    </a:lvl9pPr>
-  </p:notesStyle>
-</p:notesMaster>
-</file>
-
-<file path=ppt/notesSlides/notesSlide1.xml><?xml version="1.0" encoding="utf-8"?>
-<p:notes xmlns:a="http://schemas.openxmlformats.org/drawingml/2006/main" xmlns:p="http://schemas.openxmlformats.org/presentationml/2006/main" xmlns:r="http://schemas.openxmlformats.org/officeDocument/2006/relationships">
-  <p:cSld>
-    <p:spTree>
-      <p:nvGrpSpPr>
-        <p:cNvPr id="1" name=""/>
-        <p:cNvGrpSpPr/>
-        <p:nvPr/>
-      </p:nvGrpSpPr>
-      <p:grpSpPr>
-        <a:xfrm>
-          <a:off x="0" y="0"/>
-          <a:ext cx="0" cy="0"/>
-          <a:chOff x="0" y="0"/>
-          <a:chExt cx="0" cy="0"/>
-        </a:xfrm>
-      </p:grpSpPr>
-      <p:sp>
-        <p:nvSpPr>
-          <p:cNvPr id="2" name="Slide Image Placeholder 1"/>
-          <p:cNvSpPr>
-            <a:spLocks noGrp="1"/>
-          </p:cNvSpPr>
-          <p:nvPr>
-            <p:ph type="sldImg" idx="2"/>
-          </p:nvPr>
-        </p:nvSpPr>
-        <p:spPr/>
-      </p:sp>
-      <p:sp>
-        <p:nvSpPr>
-          <p:cNvPr id="3" name="Notes Placeholder 2"/>
-          <p:cNvSpPr>
-            <a:spLocks noGrp="1"/>
-          </p:cNvSpPr>
-          <p:nvPr>
-            <p:ph type="body" idx="3" sz="quarter"/>
-          </p:nvPr>
-        </p:nvSpPr>
-        <p:spPr/>
-        <p:txBody>
-          <a:bodyPr/>
-          <a:lstStyle/>
-          <a:p>
-            <a:r>
-              <a:t>Section 1 opener, ~45 seconds.</a:t>
-            </a:r>
-          </a:p>
-          <a:p/>
-          <a:p>
-            <a:r>
-              <a:t>The point of the slide is that the questions exist at all. Most of the room has never been asked any of the three.</a:t>
-            </a:r>
-          </a:p>
-          <a:p/>
-          <a:p>
-            <a:r>
-              <a:t>Say the open-source line out loud. This section is not a criticism of open tools; it is an argument for the kind of scrutiny only open tools permit. That framing carries the whole talk and heads off the reading that this is a hit piece on one vendor.</a:t>
-            </a:r>
-          </a:p>
-        </p:txBody>
-      </p:sp>
-      <p:sp>
-        <p:nvSpPr>
-          <p:cNvPr id="4" name="Slide Number Placeholder 3"/>
-          <p:cNvSpPr>
-            <a:spLocks noGrp="1"/>
-          </p:cNvSpPr>
-          <p:nvPr>
-            <p:ph type="sldNum" idx="5" sz="quarter"/>
-          </p:nvPr>
-        </p:nvSpPr>
-        <p:spPr/>
-      </p:sp>
-    </p:spTree>
-  </p:cSld>
-  <p:clrMapOvr>
-    <a:masterClrMapping/>
-  </p:clrMapOvr>
-</p:notes>
-</file>
-
-<file path=ppt/notesSlides/notesSlide2.xml><?xml version="1.0" encoding="utf-8"?>
-<p:notes xmlns:a="http://schemas.openxmlformats.org/drawingml/2006/main" xmlns:p="http://schemas.openxmlformats.org/presentationml/2006/main" xmlns:r="http://schemas.openxmlformats.org/officeDocument/2006/relationships">
-  <p:cSld>
-    <p:spTree>
-      <p:nvGrpSpPr>
-        <p:cNvPr id="1" name=""/>
-        <p:cNvGrpSpPr/>
-        <p:nvPr/>
-      </p:nvGrpSpPr>
-      <p:grpSpPr>
-        <a:xfrm>
-          <a:off x="0" y="0"/>
-          <a:ext cx="0" cy="0"/>
-          <a:chOff x="0" y="0"/>
-          <a:chExt cx="0" cy="0"/>
-        </a:xfrm>
-      </p:grpSpPr>
-      <p:sp>
-        <p:nvSpPr>
-          <p:cNvPr id="2" name="Slide Image Placeholder 1"/>
-          <p:cNvSpPr>
-            <a:spLocks noGrp="1"/>
-          </p:cNvSpPr>
-          <p:nvPr>
-            <p:ph type="sldImg" idx="2"/>
-          </p:nvPr>
-        </p:nvSpPr>
-        <p:spPr/>
-      </p:sp>
-      <p:sp>
-        <p:nvSpPr>
-          <p:cNvPr id="3" name="Notes Placeholder 2"/>
-          <p:cNvSpPr>
-            <a:spLocks noGrp="1"/>
-          </p:cNvSpPr>
-          <p:nvPr>
-            <p:ph type="body" idx="3" sz="quarter"/>
-          </p:nvPr>
-        </p:nvSpPr>
-        <p:spPr/>
-        <p:txBody>
-          <a:bodyPr/>
-          <a:lstStyle/>
-          <a:p>
-            <a:r>
-              <a:t>THE key mechanic: Meridian scales media by that channel’s own median non-zero per-capita execution before the saturation curve. So x = 1.0 is "what you already run", and ec_m is denominated in multiples of your own status quo.</a:t>
-            </a:r>
-          </a:p>
-          <a:p/>
-          <a:p>
-            <a:r>
-              <a:t>Prior median ec_m = 0.99x current execution.</a:t>
-            </a:r>
-          </a:p>
-          <a:p>
-            <a:r>
-              <a:t>P(past half-saturation today) = 50%.</a:t>
-            </a:r>
-          </a:p>
-          <a:p>
-            <a:r>
-              <a:t>P(&gt;1/3 of ceiling captured today) = 92%.</a:t>
-            </a:r>
-          </a:p>
-          <a:p>
-            <a:r>
-              <a:t>90% prior interval = [0.21, 2.20]x.</a:t>
-            </a:r>
-          </a:p>
-          <a:p/>
-          <a:p>
-            <a:r>
-              <a:t>The line: the model gives you coin-flip odds you are already past the point of diminishing returns, for every channel, regardless of audience size or how much of it you actually reach.</a:t>
-            </a:r>
-          </a:p>
-          <a:p/>
-          <a:p>
-            <a:r>
-              <a:t>IF ASKED "is this hidden?" — No, and do not claim it is. Google documents it: half-saturation occurs "at the median of the non-zero media units per capita across geos and time", and the truncation is justified as preserving identifiability. The point is that it is easy to miss and rarely interrogated, not that it is concealed.</a:t>
-            </a:r>
-          </a:p>
-        </p:txBody>
-      </p:sp>
-      <p:sp>
-        <p:nvSpPr>
-          <p:cNvPr id="4" name="Slide Number Placeholder 3"/>
-          <p:cNvSpPr>
-            <a:spLocks noGrp="1"/>
-          </p:cNvSpPr>
-          <p:nvPr>
-            <p:ph type="sldNum" idx="5" sz="quarter"/>
-          </p:nvPr>
-        </p:nvSpPr>
-        <p:spPr/>
-      </p:sp>
-    </p:spTree>
-  </p:cSld>
-  <p:clrMapOvr>
-    <a:masterClrMapping/>
-  </p:clrMapOvr>
-</p:notes>
-</file>
-
-<file path=ppt/notesSlides/notesSlide3.xml><?xml version="1.0" encoding="utf-8"?>
-<p:notes xmlns:a="http://schemas.openxmlformats.org/drawingml/2006/main" xmlns:p="http://schemas.openxmlformats.org/presentationml/2006/main" xmlns:r="http://schemas.openxmlformats.org/officeDocument/2006/relationships">
-  <p:cSld>
-    <p:spTree>
-      <p:nvGrpSpPr>
-        <p:cNvPr id="1" name=""/>
-        <p:cNvGrpSpPr/>
-        <p:nvPr/>
-      </p:nvGrpSpPr>
-      <p:grpSpPr>
-        <a:xfrm>
-          <a:off x="0" y="0"/>
-          <a:ext cx="0" cy="0"/>
-          <a:chOff x="0" y="0"/>
-          <a:chExt cx="0" cy="0"/>
-        </a:xfrm>
-      </p:grpSpPr>
-      <p:sp>
-        <p:nvSpPr>
-          <p:cNvPr id="2" name="Slide Image Placeholder 1"/>
-          <p:cNvSpPr>
-            <a:spLocks noGrp="1"/>
-          </p:cNvSpPr>
-          <p:nvPr>
-            <p:ph type="sldImg" idx="2"/>
-          </p:nvPr>
-        </p:nvSpPr>
-        <p:spPr/>
-      </p:sp>
-      <p:sp>
-        <p:nvSpPr>
-          <p:cNvPr id="3" name="Notes Placeholder 2"/>
-          <p:cNvSpPr>
-            <a:spLocks noGrp="1"/>
-          </p:cNvSpPr>
-          <p:nvPr>
-            <p:ph type="body" idx="3" sz="quarter"/>
-          </p:nvPr>
-        </p:nvSpPr>
-        <p:spPr/>
-        <p:txBody>
-          <a:bodyPr/>
-          <a:lstStyle/>
-          <a:p>
-            <a:r>
-              <a:t>Slope and half-saturation are the two parameters of the SAME curve, so this follows directly from the previous slide.</a:t>
-            </a:r>
-          </a:p>
-          <a:p/>
-          <a:p>
-            <a:r>
-              <a:t>slope_m is fixed, not estimated — it has no prior because it is not a random variable. Google’s stated rationale is that concave Hill curves are required so budget optimization "produces a global optimum". A legitimate engineering trade-off, and one the practitioner inherited without being asked. It forecloses exactly the effective-frequency threshold behavior most media planners believe in.</a:t>
-            </a:r>
-          </a:p>
-          <a:p/>
-          <a:p>
-            <a:r>
-              <a:t>The Robyn contrast is exact, not analogy — the two saturation functions are algebraically identical (verified numerically to ~1e-7 in prior_plots_check.py). Robyn searches alpha over [0.5, 3.0]. Meridian fixes it at 1. Same equation, opposite decision about whether the curve’s shape is knowable from data.</a:t>
-            </a:r>
-          </a:p>
-          <a:p/>
-          <a:p>
-            <a:r>
-              <a:t>READ THE RIGHT PANEL ALOUD: dots mark peak marginal return. Under the default it sits at ZERO — the model believes your first impression was your most productive one, always. At slope 2 the peak is at 0.58x today’s spend; at slope 3, 0.79x. Those build-up phases are unrepresentable at any parameter value of the default.</a:t>
-            </a:r>
-          </a:p>
-          <a:p/>
-          <a:p>
-            <a:r>
-              <a:t>FAIRNESS CAVEAT — say it: Meridian does let you override slope_m; it warns that doing so may break the optimizer’s global optimum. The claim is about the default and about which dimensions each tool searches by design, not that the door is locked.</a:t>
-            </a:r>
-          </a:p>
-        </p:txBody>
-      </p:sp>
-      <p:sp>
-        <p:nvSpPr>
-          <p:cNvPr id="4" name="Slide Number Placeholder 3"/>
-          <p:cNvSpPr>
-            <a:spLocks noGrp="1"/>
-          </p:cNvSpPr>
-          <p:nvPr>
-            <p:ph type="sldNum" idx="5" sz="quarter"/>
-          </p:nvPr>
-        </p:nvSpPr>
-        <p:spPr/>
-      </p:sp>
-    </p:spTree>
-  </p:cSld>
-  <p:clrMapOvr>
-    <a:masterClrMapping/>
-  </p:clrMapOvr>
-</p:notes>
-</file>
-
-<file path=ppt/notesSlides/notesSlide4.xml><?xml version="1.0" encoding="utf-8"?>
-<p:notes xmlns:a="http://schemas.openxmlformats.org/drawingml/2006/main" xmlns:p="http://schemas.openxmlformats.org/presentationml/2006/main" xmlns:r="http://schemas.openxmlformats.org/officeDocument/2006/relationships">
-  <p:cSld>
-    <p:spTree>
-      <p:nvGrpSpPr>
-        <p:cNvPr id="1" name=""/>
-        <p:cNvGrpSpPr/>
-        <p:nvPr/>
-      </p:nvGrpSpPr>
-      <p:grpSpPr>
-        <a:xfrm>
-          <a:off x="0" y="0"/>
-          <a:ext cx="0" cy="0"/>
-          <a:chOff x="0" y="0"/>
-          <a:chExt cx="0" cy="0"/>
-        </a:xfrm>
-      </p:grpSpPr>
-      <p:sp>
-        <p:nvSpPr>
-          <p:cNvPr id="2" name="Slide Image Placeholder 1"/>
-          <p:cNvSpPr>
-            <a:spLocks noGrp="1"/>
-          </p:cNvSpPr>
-          <p:nvPr>
-            <p:ph type="sldImg" idx="2"/>
-          </p:nvPr>
-        </p:nvSpPr>
-        <p:spPr/>
-      </p:sp>
-      <p:sp>
-        <p:nvSpPr>
-          <p:cNvPr id="3" name="Notes Placeholder 2"/>
-          <p:cNvSpPr>
-            <a:spLocks noGrp="1"/>
-          </p:cNvSpPr>
-          <p:nvPr>
-            <p:ph type="body" idx="3" sz="quarter"/>
-          </p:nvPr>
-        </p:nvSpPr>
-        <p:spPr/>
-        <p:txBody>
-          <a:bodyPr/>
-          <a:lstStyle/>
-          <a:p>
-            <a:r>
-              <a:t>SET THIS UP AS A DELIBERATE CONTRAST. alpha_m ~ Uniform(0,1) genuinely is flat, and Google describes it as uninformative so the data can inform decay. There is no skew story here. If the section stopped at the saturation slide it would read as tool-bashing.</a:t>
-            </a:r>
-          </a:p>
-          <a:p/>
-          <a:p>
-            <a:r>
-              <a:t>(a) Flat on the parameter is not flat on what you care about. Nobody decides about "alpha"; they decide about WHEN advertising works. Translated: median 50% of effect in week 0, 30% chance mostly immediate (&gt;=70% week 0), 28% chance mostly lingering (&lt;=30%). Nearly bimodal on the only question a planner would ask.</a:t>
-            </a:r>
-          </a:p>
-          <a:p/>
-          <a:p>
-            <a:r>
-              <a:t>(b) The binding assumption is not a prior at all. max_lag = 8 is a hard truncation in the model spec — never estimated, no prior, no posterior uncertainty. At decay 0.9, 39% of true carryover falls beyond week 8 and is discarded and renormalized away. If your TV genuinely works over a quarter, the default cannot see it, and nothing in the output tells you so.</a:t>
-            </a:r>
-          </a:p>
-          <a:p/>
-          <a:p>
-            <a:r>
-              <a:t>(c) Robyn bounds decay per channel type, encoding the ordinary planning knowledge that TV lingers and digital does not.</a:t>
-            </a:r>
-          </a:p>
-          <a:p/>
-          <a:p>
-            <a:r>
-              <a:t>THE TAXONOMY IS THE THESIS: some defaults are skewed toward a conclusion; some are flat on the parameter but misleading on the decision; some are not priors at all, but hard-coded structure wearing the costume of neutrality. Land that, then move to the TV case study.</a:t>
-            </a:r>
-          </a:p>
-          <a:p/>
-          <a:p>
-            <a:r>
-              <a:t>CAVEAT for any Robyn claim: Robyn is ridge regression with Nevergrad search, not Bayesian — those are search bounds, not priors. Say it before a Robyn user in the room says it for you.</a:t>
-            </a:r>
-          </a:p>
-        </p:txBody>
-      </p:sp>
-      <p:sp>
-        <p:nvSpPr>
-          <p:cNvPr id="4" name="Slide Number Placeholder 3"/>
-          <p:cNvSpPr>
-            <a:spLocks noGrp="1"/>
-          </p:cNvSpPr>
-          <p:nvPr>
-            <p:ph type="sldNum" idx="5" sz="quarter"/>
-          </p:nvPr>
-        </p:nvSpPr>
-        <p:spPr/>
-      </p:sp>
-    </p:spTree>
-  </p:cSld>
-  <p:clrMapOvr>
-    <a:masterClrMapping/>
-  </p:clrMapOvr>
-</p:notes>
 </file>
 
 <file path=ppt/slideLayouts/slideLayout1.xml><?xml version="1.0" encoding="utf-8"?>
@@ -4011,7 +3287,7 @@
               </a:defRPr>
             </a:pPr>
             <a:r>
-              <a:t>We can inspect these choices only because Meridian and Robyn are open source — that is a credit to both. Every closed MMM makes the same three choices, unauditably.</a:t>
+              <a:t>We can inspect these choices only because Meridian is open source — every closed MMM makes the same three choices, unauditably.</a:t>
             </a:r>
           </a:p>
         </p:txBody>
@@ -4103,8 +3379,8 @@
         </p:blipFill>
         <p:spPr>
           <a:xfrm>
-            <a:off x="1680291" y="1417320"/>
-            <a:ext cx="8831112" cy="3657600"/>
+            <a:off x="1664072" y="1417320"/>
+            <a:ext cx="8863550" cy="3657600"/>
           </a:xfrm>
           <a:prstGeom prst="rect">
             <a:avLst/>
@@ -4145,21 +3421,6 @@
             </a:pPr>
             <a:r>
               <a:t>Out of the box: 50% odds you are already past half-saturation, and 92% odds you have captured more than a third of the channel’s maximum effect — applied identically to every channel, whatever its audience or reach.</a:t>
-            </a:r>
-          </a:p>
-          <a:p>
-            <a:pPr>
-              <a:spcAft>
-                <a:spcPts val="600"/>
-              </a:spcAft>
-              <a:defRPr sz="1200" b="0">
-                <a:solidFill>
-                  <a:srgbClr val="5A5A5A"/>
-                </a:solidFill>
-              </a:defRPr>
-            </a:pPr>
-            <a:r>
-              <a:t>Robyn makes the same category of choice: its gamma plays this role and is searched over [0.3, 1], also identically across channels.</a:t>
             </a:r>
           </a:p>
         </p:txBody>
@@ -4289,8 +3550,8 @@
         </p:blipFill>
         <p:spPr>
           <a:xfrm>
-            <a:off x="1678618" y="1417320"/>
-            <a:ext cx="8834459" cy="3657600"/>
+            <a:off x="1668138" y="1417320"/>
+            <a:ext cx="8855418" cy="3657600"/>
           </a:xfrm>
           <a:prstGeom prst="rect">
             <a:avLst/>
@@ -4333,21 +3594,6 @@
               <a:t>Fixing the slope at 1 means diminishing returns from the very first impression — no build-up, no threshold effect. The stated reason is tractability, not advertising: concave curves guarantee the budget optimizer a global optimum.</a:t>
             </a:r>
           </a:p>
-          <a:p>
-            <a:pPr>
-              <a:spcAft>
-                <a:spcPts val="600"/>
-              </a:spcAft>
-              <a:defRPr sz="1200" b="0">
-                <a:solidFill>
-                  <a:srgbClr val="5A5A5A"/>
-                </a:solidFill>
-              </a:defRPr>
-            </a:pPr>
-            <a:r>
-              <a:t>Identical Hill equation in both tools (gamma ≡ ec_m, alpha ≡ slope_m). Robyn searches alpha over [0.5, 3.0], spanning C- through S-shape; Meridian fixes it at 1.</a:t>
-            </a:r>
-          </a:p>
         </p:txBody>
       </p:sp>
       <p:sp>
@@ -4383,7 +3629,7 @@
               </a:defRPr>
             </a:pPr>
             <a:r>
-              <a:t>Meridian: hill(x) = x^slope / (x^slope + ec^slope).   Robyn: saturated = 1 / (1 + (gamma/adstocked)^alpha).   https://facebookexperimental.github.io/Robyn/docs/analysts-guide-to-MMM</a:t>
+              <a:t>Meridian: hill(x) = x^slope / (x^slope + ec^slope).</a:t>
             </a:r>
           </a:p>
         </p:txBody>
@@ -4439,7 +3685,7 @@
               </a:defRPr>
             </a:pPr>
             <a:r>
-              <a:t>Assumption 3 — Adstock: flat is not neutral, and the real assumption is not a prior</a:t>
+              <a:t>Assumption 3 — Adstock: a fair prior, and a hard cutoff behind it</a:t>
             </a:r>
           </a:p>
           <a:p>
@@ -4454,7 +3700,7 @@
               </a:defRPr>
             </a:pPr>
             <a:r>
-              <a:t>alpha_m ~ Uniform(0, 1) genuinely is flat. The problem is elsewhere.</a:t>
+              <a:t>alpha_m ~ Uniform(0, 1) is honestly flat — no skew to complain about here. The binding assumption sits elsewhere.</a:t>
             </a:r>
           </a:p>
         </p:txBody>
@@ -4475,8 +3721,8 @@
         </p:blipFill>
         <p:spPr>
           <a:xfrm>
-            <a:off x="1678618" y="1417320"/>
-            <a:ext cx="8834459" cy="3657600"/>
+            <a:off x="1664072" y="1417320"/>
+            <a:ext cx="8863550" cy="3657600"/>
           </a:xfrm>
           <a:prstGeom prst="rect">
             <a:avLst/>
@@ -4492,7 +3738,7 @@
         <p:spPr>
           <a:xfrm>
             <a:off x="548640" y="5212080"/>
-            <a:ext cx="11064240" cy="1463040"/>
+            <a:ext cx="11064240" cy="1188720"/>
           </a:xfrm>
           <a:prstGeom prst="rect">
             <a:avLst/>
@@ -4516,7 +3762,7 @@
               </a:defRPr>
             </a:pPr>
             <a:r>
-              <a:t>Flat on the parameter is not flat on the decision: the implied share of effect landing in week 0 has median 50%, with a 30% chance it is mostly immediate and a 28% chance it mostly lingers.</a:t>
+              <a:t>Decay rate alone is not interpretable — half-life is. The same flat prior spans routines from a 0.6-week half-life at alpha=0.3 to a 6.6-week half-life at alpha=0.9.</a:t>
             </a:r>
           </a:p>
           <a:p>
@@ -4531,7 +3777,63 @@
               </a:defRPr>
             </a:pPr>
             <a:r>
-              <a:t>And the binding assumption is not a prior at all: max_lag = 8 is a hard truncation, never estimated. At a decay rate of 0.9, 39% of true carryover falls beyond week 8 and is discarded.</a:t>
+              <a:t>And the binding assumption is not a prior at all: max_lag = 8 is a hard truncation, never estimated. At a decay rate of 0.9 (6.6-week half-life), 39% of true carryover falls beyond week 8 and is silently discarded.</a:t>
+            </a:r>
+          </a:p>
+        </p:txBody>
+      </p:sp>
+    </p:spTree>
+  </p:cSld>
+  <p:clrMapOvr>
+    <a:masterClrMapping/>
+  </p:clrMapOvr>
+</p:sld>
+</file>
+
+<file path=ppt/slides/slide5.xml><?xml version="1.0" encoding="utf-8"?>
+<p:sld xmlns:a="http://schemas.openxmlformats.org/drawingml/2006/main" xmlns:p="http://schemas.openxmlformats.org/presentationml/2006/main" xmlns:r="http://schemas.openxmlformats.org/officeDocument/2006/relationships">
+  <p:cSld>
+    <p:spTree>
+      <p:nvGrpSpPr>
+        <p:cNvPr id="1" name=""/>
+        <p:cNvGrpSpPr/>
+        <p:nvPr/>
+      </p:nvGrpSpPr>
+      <p:grpSpPr/>
+      <p:sp>
+        <p:nvSpPr>
+          <p:cNvPr id="2" name="TextBox 1"/>
+          <p:cNvSpPr txBox="1"/>
+          <p:nvPr/>
+        </p:nvSpPr>
+        <p:spPr>
+          <a:xfrm>
+            <a:off x="548640" y="320040"/>
+            <a:ext cx="11064240" cy="914400"/>
+          </a:xfrm>
+          <a:prstGeom prst="rect">
+            <a:avLst/>
+          </a:prstGeom>
+          <a:noFill/>
+        </p:spPr>
+        <p:txBody>
+          <a:bodyPr wrap="square" tIns="0">
+            <a:spAutoFit/>
+          </a:bodyPr>
+          <a:lstStyle/>
+          <a:p>
+            <a:pPr>
+              <a:spcAft>
+                <a:spcPts val="200"/>
+              </a:spcAft>
+              <a:defRPr sz="3000" b="1">
+                <a:solidFill>
+                  <a:srgbClr val="1A1A1A"/>
+                </a:solidFill>
+              </a:defRPr>
+            </a:pPr>
+            <a:r>
+              <a:t>Simulated data with known ground truth</a:t>
             </a:r>
           </a:p>
           <a:p>
@@ -4539,6 +3841,534 @@
               <a:spcAft>
                 <a:spcPts val="600"/>
               </a:spcAft>
+              <a:defRPr sz="1500" b="0">
+                <a:solidFill>
+                  <a:srgbClr val="5A5A5A"/>
+                </a:solidFill>
+              </a:defRPr>
+            </a:pPr>
+            <a:r>
+              <a:t>In the real world the true saturation point is never observed, only the fitted one. So: simulate geo × time data from a known generative model, fit an MMM to it, and check whether it recovers the truth it was built from.</a:t>
+            </a:r>
+          </a:p>
+        </p:txBody>
+      </p:sp>
+      <p:sp>
+        <p:nvSpPr>
+          <p:cNvPr id="3" name="TextBox 2"/>
+          <p:cNvSpPr txBox="1"/>
+          <p:nvPr/>
+        </p:nvSpPr>
+        <p:spPr>
+          <a:xfrm>
+            <a:off x="548640" y="1554480"/>
+            <a:ext cx="6400800" cy="822960"/>
+          </a:xfrm>
+          <a:prstGeom prst="rect">
+            <a:avLst/>
+          </a:prstGeom>
+          <a:noFill/>
+        </p:spPr>
+        <p:txBody>
+          <a:bodyPr wrap="square" tIns="0">
+            <a:spAutoFit/>
+          </a:bodyPr>
+          <a:lstStyle/>
+          <a:p>
+            <a:pPr>
+              <a:spcAft>
+                <a:spcPts val="800"/>
+              </a:spcAft>
+              <a:defRPr sz="1500" b="1">
+                <a:solidFill>
+                  <a:srgbClr val="2C7FB8"/>
+                </a:solidFill>
+              </a:defRPr>
+            </a:pPr>
+            <a:r>
+              <a:t>Realistic Data Generation Process</a:t>
+            </a:r>
+          </a:p>
+          <a:p>
+            <a:pPr>
+              <a:spcAft>
+                <a:spcPts val="1000"/>
+              </a:spcAft>
+              <a:defRPr sz="1400" b="1">
+                <a:solidFill>
+                  <a:srgbClr val="1A1A1A"/>
+                </a:solidFill>
+              </a:defRPr>
+            </a:pPr>
+            <a:r>
+              <a:t>Sales_g,t  =  Intercept_g</a:t>
+            </a:r>
+          </a:p>
+        </p:txBody>
+      </p:sp>
+      <p:sp>
+        <p:nvSpPr>
+          <p:cNvPr id="4" name="TextBox 3"/>
+          <p:cNvSpPr txBox="1"/>
+          <p:nvPr/>
+        </p:nvSpPr>
+        <p:spPr>
+          <a:xfrm>
+            <a:off x="868680" y="2468880"/>
+            <a:ext cx="6080760" cy="2194560"/>
+          </a:xfrm>
+          <a:prstGeom prst="rect">
+            <a:avLst/>
+          </a:prstGeom>
+          <a:noFill/>
+        </p:spPr>
+        <p:txBody>
+          <a:bodyPr wrap="square" tIns="0">
+            <a:spAutoFit/>
+          </a:bodyPr>
+          <a:lstStyle/>
+          <a:p>
+            <a:pPr>
+              <a:spcAft>
+                <a:spcPts val="600"/>
+              </a:spcAft>
+              <a:defRPr sz="1300" b="1">
+                <a:solidFill>
+                  <a:srgbClr val="1A1A1A"/>
+                </a:solidFill>
+              </a:defRPr>
+            </a:pPr>
+            <a:r>
+              <a:t>+   Trend_t</a:t>
+            </a:r>
+          </a:p>
+          <a:p>
+            <a:pPr>
+              <a:spcAft>
+                <a:spcPts val="600"/>
+              </a:spcAft>
+              <a:defRPr sz="1300" b="1">
+                <a:solidFill>
+                  <a:srgbClr val="1A1A1A"/>
+                </a:solidFill>
+              </a:defRPr>
+            </a:pPr>
+            <a:r>
+              <a:t>+   Seasonality_t</a:t>
+            </a:r>
+          </a:p>
+          <a:p>
+            <a:pPr>
+              <a:spcAft>
+                <a:spcPts val="600"/>
+              </a:spcAft>
+              <a:defRPr sz="1300" b="1">
+                <a:solidFill>
+                  <a:srgbClr val="1A1A1A"/>
+                </a:solidFill>
+              </a:defRPr>
+            </a:pPr>
+            <a:r>
+              <a:t>+   SharedShock_t</a:t>
+            </a:r>
+          </a:p>
+          <a:p>
+            <a:pPr>
+              <a:spcAft>
+                <a:spcPts val="600"/>
+              </a:spcAft>
+              <a:defRPr sz="1300" b="1">
+                <a:solidFill>
+                  <a:srgbClr val="1A1A1A"/>
+                </a:solidFill>
+              </a:defRPr>
+            </a:pPr>
+            <a:r>
+              <a:t>+   Σ_c ControlWeight_g,c · Control_g,t,c</a:t>
+            </a:r>
+          </a:p>
+          <a:p>
+            <a:pPr>
+              <a:spcAft>
+                <a:spcPts val="600"/>
+              </a:spcAft>
+              <a:defRPr sz="1300" b="1">
+                <a:solidFill>
+                  <a:srgbClr val="1A1A1A"/>
+                </a:solidFill>
+              </a:defRPr>
+            </a:pPr>
+            <a:r>
+              <a:t>+   Σ_m Coefficient_g,m · Saturation( Carryover(Impressions_g,t,m; Decay_m) ; HalfSaturation_m, Slope_m )</a:t>
+            </a:r>
+          </a:p>
+          <a:p>
+            <a:pPr>
+              <a:spcAft>
+                <a:spcPts val="600"/>
+              </a:spcAft>
+              <a:defRPr sz="1300" b="1">
+                <a:solidFill>
+                  <a:srgbClr val="1A1A1A"/>
+                </a:solidFill>
+              </a:defRPr>
+            </a:pPr>
+            <a:r>
+              <a:t>+   Noise_g,t</a:t>
+            </a:r>
+          </a:p>
+        </p:txBody>
+      </p:sp>
+      <p:pic>
+        <p:nvPicPr>
+          <p:cNvPr id="5" name="Picture 4" descr="slide5_series_r90.png"/>
+          <p:cNvPicPr>
+            <a:picLocks noChangeAspect="1"/>
+          </p:cNvPicPr>
+          <p:nvPr/>
+        </p:nvPicPr>
+        <p:blipFill>
+          <a:blip r:embed="rId2"/>
+          <a:stretch>
+            <a:fillRect/>
+          </a:stretch>
+        </p:blipFill>
+        <p:spPr>
+          <a:xfrm>
+            <a:off x="7315200" y="1325880"/>
+            <a:ext cx="4343400" cy="4452795"/>
+          </a:xfrm>
+          <a:prstGeom prst="rect">
+            <a:avLst/>
+          </a:prstGeom>
+        </p:spPr>
+      </p:pic>
+      <p:sp>
+        <p:nvSpPr>
+          <p:cNvPr id="6" name="TextBox 5"/>
+          <p:cNvSpPr txBox="1"/>
+          <p:nvPr/>
+        </p:nvSpPr>
+        <p:spPr>
+          <a:xfrm>
+            <a:off x="548640" y="4343400"/>
+            <a:ext cx="6400800" cy="365760"/>
+          </a:xfrm>
+          <a:prstGeom prst="rect">
+            <a:avLst/>
+          </a:prstGeom>
+          <a:noFill/>
+        </p:spPr>
+        <p:txBody>
+          <a:bodyPr wrap="square" tIns="0">
+            <a:spAutoFit/>
+          </a:bodyPr>
+          <a:lstStyle/>
+          <a:p>
+            <a:pPr>
+              <a:spcAft>
+                <a:spcPts val="600"/>
+              </a:spcAft>
+              <a:defRPr sz="1500" b="1">
+                <a:solidFill>
+                  <a:srgbClr val="1A1A1A"/>
+                </a:solidFill>
+              </a:defRPr>
+            </a:pPr>
+            <a:r>
+              <a:t>What we know that no real dataset tells you — across all 10 simulated datasets</a:t>
+            </a:r>
+          </a:p>
+        </p:txBody>
+      </p:sp>
+      <p:graphicFrame>
+        <p:nvGraphicFramePr>
+          <p:cNvPr id="7" name="Table 6"/>
+          <p:cNvGraphicFramePr>
+            <a:graphicFrameLocks noGrp="1"/>
+          </p:cNvGraphicFramePr>
+          <p:nvPr/>
+        </p:nvGraphicFramePr>
+        <p:xfrm>
+          <a:off x="548640" y="4709160"/>
+          <a:ext cx="6400800" cy="1152144"/>
+        </p:xfrm>
+        <a:graphic>
+          <a:graphicData uri="http://schemas.openxmlformats.org/drawingml/2006/table">
+            <a:tbl>
+              <a:tblPr firstRow="1" bandRow="1">
+                <a:tableStyleId>{5C22544A-7EE6-4342-B048-85BDC9FD1C3A}</a:tableStyleId>
+              </a:tblPr>
+              <a:tblGrid>
+                <a:gridCol w="1371600"/>
+                <a:gridCol w="2377440"/>
+                <a:gridCol w="1280160"/>
+                <a:gridCol w="1371600"/>
+              </a:tblGrid>
+              <a:tr h="384048">
+                <a:tc>
+                  <a:txBody>
+                    <a:bodyPr/>
+                    <a:lstStyle/>
+                    <a:p>
+                      <a:pPr>
+                        <a:defRPr sz="1200" b="1">
+                          <a:solidFill>
+                            <a:srgbClr val="1A1A1A"/>
+                          </a:solidFill>
+                        </a:defRPr>
+                      </a:pPr>
+                      <a:r>
+                        <a:t>Channel</a:t>
+                      </a:r>
+                    </a:p>
+                  </a:txBody>
+                  <a:tcPr/>
+                </a:tc>
+                <a:tc>
+                  <a:txBody>
+                    <a:bodyPr/>
+                    <a:lstStyle/>
+                    <a:p>
+                      <a:pPr>
+                        <a:defRPr sz="1200" b="1">
+                          <a:solidFill>
+                            <a:srgbClr val="1A1A1A"/>
+                          </a:solidFill>
+                        </a:defRPr>
+                      </a:pPr>
+                      <a:r>
+                        <a:t>Half-saturation (× current delivery)</a:t>
+                      </a:r>
+                    </a:p>
+                  </a:txBody>
+                  <a:tcPr/>
+                </a:tc>
+                <a:tc>
+                  <a:txBody>
+                    <a:bodyPr/>
+                    <a:lstStyle/>
+                    <a:p>
+                      <a:pPr>
+                        <a:defRPr sz="1200" b="1">
+                          <a:solidFill>
+                            <a:srgbClr val="1A1A1A"/>
+                          </a:solidFill>
+                        </a:defRPr>
+                      </a:pPr>
+                      <a:r>
+                        <a:t>True ROI</a:t>
+                      </a:r>
+                    </a:p>
+                  </a:txBody>
+                  <a:tcPr/>
+                </a:tc>
+                <a:tc>
+                  <a:txBody>
+                    <a:bodyPr/>
+                    <a:lstStyle/>
+                    <a:p>
+                      <a:pPr>
+                        <a:defRPr sz="1200" b="1">
+                          <a:solidFill>
+                            <a:srgbClr val="1A1A1A"/>
+                          </a:solidFill>
+                        </a:defRPr>
+                      </a:pPr>
+                      <a:r>
+                        <a:t>True carryover (α)</a:t>
+                      </a:r>
+                    </a:p>
+                  </a:txBody>
+                  <a:tcPr/>
+                </a:tc>
+              </a:tr>
+              <a:tr h="384048">
+                <a:tc>
+                  <a:txBody>
+                    <a:bodyPr/>
+                    <a:lstStyle/>
+                    <a:p>
+                      <a:pPr>
+                        <a:defRPr sz="1200">
+                          <a:solidFill>
+                            <a:srgbClr val="1A1A1A"/>
+                          </a:solidFill>
+                        </a:defRPr>
+                      </a:pPr>
+                      <a:r>
+                        <a:t>Channel-2</a:t>
+                      </a:r>
+                    </a:p>
+                  </a:txBody>
+                  <a:tcPr/>
+                </a:tc>
+                <a:tc>
+                  <a:txBody>
+                    <a:bodyPr/>
+                    <a:lstStyle/>
+                    <a:p>
+                      <a:pPr>
+                        <a:defRPr sz="1200">
+                          <a:solidFill>
+                            <a:srgbClr val="1A1A1A"/>
+                          </a:solidFill>
+                        </a:defRPr>
+                      </a:pPr>
+                      <a:r>
+                        <a:t>1.30×</a:t>
+                      </a:r>
+                    </a:p>
+                  </a:txBody>
+                  <a:tcPr/>
+                </a:tc>
+                <a:tc>
+                  <a:txBody>
+                    <a:bodyPr/>
+                    <a:lstStyle/>
+                    <a:p>
+                      <a:pPr>
+                        <a:defRPr sz="1200">
+                          <a:solidFill>
+                            <a:srgbClr val="1A1A1A"/>
+                          </a:solidFill>
+                        </a:defRPr>
+                      </a:pPr>
+                      <a:r>
+                        <a:t>6.0</a:t>
+                      </a:r>
+                    </a:p>
+                  </a:txBody>
+                  <a:tcPr/>
+                </a:tc>
+                <a:tc>
+                  <a:txBody>
+                    <a:bodyPr/>
+                    <a:lstStyle/>
+                    <a:p>
+                      <a:pPr>
+                        <a:defRPr sz="1200">
+                          <a:solidFill>
+                            <a:srgbClr val="1A1A1A"/>
+                          </a:solidFill>
+                        </a:defRPr>
+                      </a:pPr>
+                      <a:r>
+                        <a:t>0.15</a:t>
+                      </a:r>
+                    </a:p>
+                  </a:txBody>
+                  <a:tcPr/>
+                </a:tc>
+              </a:tr>
+              <a:tr h="384048">
+                <a:tc>
+                  <a:txBody>
+                    <a:bodyPr/>
+                    <a:lstStyle/>
+                    <a:p>
+                      <a:pPr>
+                        <a:defRPr sz="1200">
+                          <a:solidFill>
+                            <a:srgbClr val="1A1A1A"/>
+                          </a:solidFill>
+                        </a:defRPr>
+                      </a:pPr>
+                      <a:r>
+                        <a:t>Channel-1</a:t>
+                      </a:r>
+                    </a:p>
+                  </a:txBody>
+                  <a:tcPr/>
+                </a:tc>
+                <a:tc>
+                  <a:txBody>
+                    <a:bodyPr/>
+                    <a:lstStyle/>
+                    <a:p>
+                      <a:pPr>
+                        <a:defRPr sz="1200">
+                          <a:solidFill>
+                            <a:srgbClr val="1A1A1A"/>
+                          </a:solidFill>
+                        </a:defRPr>
+                      </a:pPr>
+                      <a:r>
+                        <a:t>9.00×</a:t>
+                      </a:r>
+                    </a:p>
+                  </a:txBody>
+                  <a:tcPr/>
+                </a:tc>
+                <a:tc>
+                  <a:txBody>
+                    <a:bodyPr/>
+                    <a:lstStyle/>
+                    <a:p>
+                      <a:pPr>
+                        <a:defRPr sz="1200">
+                          <a:solidFill>
+                            <a:srgbClr val="1A1A1A"/>
+                          </a:solidFill>
+                        </a:defRPr>
+                      </a:pPr>
+                      <a:r>
+                        <a:t>6.6</a:t>
+                      </a:r>
+                    </a:p>
+                  </a:txBody>
+                  <a:tcPr/>
+                </a:tc>
+                <a:tc>
+                  <a:txBody>
+                    <a:bodyPr/>
+                    <a:lstStyle/>
+                    <a:p>
+                      <a:pPr>
+                        <a:defRPr sz="1200">
+                          <a:solidFill>
+                            <a:srgbClr val="1A1A1A"/>
+                          </a:solidFill>
+                        </a:defRPr>
+                      </a:pPr>
+                      <a:r>
+                        <a:t>0.30</a:t>
+                      </a:r>
+                    </a:p>
+                  </a:txBody>
+                  <a:tcPr/>
+                </a:tc>
+              </a:tr>
+            </a:tbl>
+          </a:graphicData>
+        </a:graphic>
+      </p:graphicFrame>
+      <p:sp>
+        <p:nvSpPr>
+          <p:cNvPr id="8" name="TextBox 7"/>
+          <p:cNvSpPr txBox="1"/>
+          <p:nvPr/>
+        </p:nvSpPr>
+        <p:spPr>
+          <a:xfrm>
+            <a:off x="548640" y="5989320"/>
+            <a:ext cx="6400800" cy="457200"/>
+          </a:xfrm>
+          <a:prstGeom prst="rect">
+            <a:avLst/>
+          </a:prstGeom>
+          <a:noFill/>
+        </p:spPr>
+        <p:txBody>
+          <a:bodyPr wrap="square" tIns="0">
+            <a:spAutoFit/>
+          </a:bodyPr>
+          <a:lstStyle/>
+          <a:p>
+            <a:pPr>
+              <a:spcAft>
+                <a:spcPts val="600"/>
+              </a:spcAft>
               <a:defRPr sz="1200" b="0">
                 <a:solidFill>
                   <a:srgbClr val="5A5A5A"/>
@@ -4546,7 +4376,998 @@
               </a:defRPr>
             </a:pPr>
             <a:r>
-              <a:t>Robyn bounds decay per channel type — TV [0.3, 0.8], OOH/print/radio [0.1, 0.4], digital [0, 0.3]. Meridian applies one Uniform(0, 1) to every channel.</a:t>
+              <a:t>20 regions × 156 weeks, media 32% of the outcome — a well-powered dataset, not a starved one.</a:t>
+            </a:r>
+          </a:p>
+        </p:txBody>
+      </p:sp>
+      <p:sp>
+        <p:nvSpPr>
+          <p:cNvPr id="9" name="TextBox 8"/>
+          <p:cNvSpPr txBox="1"/>
+          <p:nvPr/>
+        </p:nvSpPr>
+        <p:spPr>
+          <a:xfrm>
+            <a:off x="548640" y="6446520"/>
+            <a:ext cx="11064240" cy="320040"/>
+          </a:xfrm>
+          <a:prstGeom prst="rect">
+            <a:avLst/>
+          </a:prstGeom>
+          <a:noFill/>
+        </p:spPr>
+        <p:txBody>
+          <a:bodyPr wrap="square" tIns="0">
+            <a:spAutoFit/>
+          </a:bodyPr>
+          <a:lstStyle/>
+          <a:p>
+            <a:pPr>
+              <a:spcAft>
+                <a:spcPts val="600"/>
+              </a:spcAft>
+              <a:defRPr sz="900" b="0">
+                <a:solidFill>
+                  <a:srgbClr val="5A5A5A"/>
+                </a:solidFill>
+              </a:defRPr>
+            </a:pPr>
+            <a:r>
+              <a:t>Ranges span the 10 simulated datasets the results slides pool. A single value means the quantity is pinned across all of them by construction, so the comparison isolates it; ROI is re-derived from whatever data each draw produces, so it moves. The specific saturation threshold is a stated modelling assumption, not a claim about real-world saturation; what is being tested is the mechanism, not that number.</a:t>
+            </a:r>
+          </a:p>
+        </p:txBody>
+      </p:sp>
+    </p:spTree>
+  </p:cSld>
+  <p:clrMapOvr>
+    <a:masterClrMapping/>
+  </p:clrMapOvr>
+</p:sld>
+</file>
+
+<file path=ppt/slides/slide6.xml><?xml version="1.0" encoding="utf-8"?>
+<p:sld xmlns:a="http://schemas.openxmlformats.org/drawingml/2006/main" xmlns:p="http://schemas.openxmlformats.org/presentationml/2006/main" xmlns:r="http://schemas.openxmlformats.org/officeDocument/2006/relationships">
+  <p:cSld>
+    <p:spTree>
+      <p:nvGrpSpPr>
+        <p:cNvPr id="1" name=""/>
+        <p:cNvGrpSpPr/>
+        <p:nvPr/>
+      </p:nvGrpSpPr>
+      <p:grpSpPr/>
+      <p:sp>
+        <p:nvSpPr>
+          <p:cNvPr id="2" name="TextBox 1"/>
+          <p:cNvSpPr txBox="1"/>
+          <p:nvPr/>
+        </p:nvSpPr>
+        <p:spPr>
+          <a:xfrm>
+            <a:off x="548640" y="320040"/>
+            <a:ext cx="11064240" cy="914400"/>
+          </a:xfrm>
+          <a:prstGeom prst="rect">
+            <a:avLst/>
+          </a:prstGeom>
+          <a:noFill/>
+        </p:spPr>
+        <p:txBody>
+          <a:bodyPr wrap="square" tIns="0">
+            <a:spAutoFit/>
+          </a:bodyPr>
+          <a:lstStyle/>
+          <a:p>
+            <a:pPr>
+              <a:spcAft>
+                <a:spcPts val="200"/>
+              </a:spcAft>
+              <a:defRPr sz="3000" b="1">
+                <a:solidFill>
+                  <a:srgbClr val="1A1A1A"/>
+                </a:solidFill>
+              </a:defRPr>
+            </a:pPr>
+            <a:r>
+              <a:t>Where the spend actually sits on each channel’s own curve</a:t>
+            </a:r>
+          </a:p>
+          <a:p>
+            <a:pPr>
+              <a:spcAft>
+                <a:spcPts val="600"/>
+              </a:spcAft>
+              <a:defRPr sz="1500" b="0">
+                <a:solidFill>
+                  <a:srgbClr val="5A5A5A"/>
+                </a:solidFill>
+              </a:defRPr>
+            </a:pPr>
+            <a:r>
+              <a:t>Same x-axis as slide 2: media measured in multiples of that channel’s own median week, so 1.0 is "what you already run".</a:t>
+            </a:r>
+          </a:p>
+        </p:txBody>
+      </p:sp>
+      <p:pic>
+        <p:nvPicPr>
+          <p:cNvPr id="3" name="Picture 2" descr="results_execution_vs_curve.png"/>
+          <p:cNvPicPr>
+            <a:picLocks noChangeAspect="1"/>
+          </p:cNvPicPr>
+          <p:nvPr/>
+        </p:nvPicPr>
+        <p:blipFill>
+          <a:blip r:embed="rId2"/>
+          <a:stretch>
+            <a:fillRect/>
+          </a:stretch>
+        </p:blipFill>
+        <p:spPr>
+          <a:xfrm>
+            <a:off x="1228350" y="1600200"/>
+            <a:ext cx="9734994" cy="3749039"/>
+          </a:xfrm>
+          <a:prstGeom prst="rect">
+            <a:avLst/>
+          </a:prstGeom>
+        </p:spPr>
+      </p:pic>
+      <p:sp>
+        <p:nvSpPr>
+          <p:cNvPr id="4" name="TextBox 3"/>
+          <p:cNvSpPr txBox="1"/>
+          <p:nvPr/>
+        </p:nvSpPr>
+        <p:spPr>
+          <a:xfrm>
+            <a:off x="548640" y="5532120"/>
+            <a:ext cx="11064240" cy="914400"/>
+          </a:xfrm>
+          <a:prstGeom prst="rect">
+            <a:avLst/>
+          </a:prstGeom>
+          <a:noFill/>
+        </p:spPr>
+        <p:txBody>
+          <a:bodyPr wrap="square" tIns="0">
+            <a:spAutoFit/>
+          </a:bodyPr>
+          <a:lstStyle/>
+          <a:p>
+            <a:pPr>
+              <a:spcAft>
+                <a:spcPts val="600"/>
+              </a:spcAft>
+              <a:defRPr sz="1500" b="1">
+                <a:solidFill>
+                  <a:srgbClr val="C0392B"/>
+                </a:solidFill>
+              </a:defRPr>
+            </a:pPr>
+            <a:r>
+              <a:t>Channel-1 is running at 10.0% of its ceiling — every week of it sits on the straight part of its own curve. Channel-2, at 43.6%, is up around the bend.</a:t>
+            </a:r>
+          </a:p>
+          <a:p>
+            <a:pPr>
+              <a:spcAft>
+                <a:spcPts val="600"/>
+              </a:spcAft>
+              <a:defRPr sz="1200" b="0">
+                <a:solidFill>
+                  <a:srgbClr val="5A5A5A"/>
+                </a:solidFill>
+              </a:defRPr>
+            </a:pPr>
+            <a:r>
+              <a:t>This is the whole setup: one genuinely under-invested channel, one that is not. No statistics yet — just where the money currently lands.</a:t>
+            </a:r>
+          </a:p>
+        </p:txBody>
+      </p:sp>
+      <p:sp>
+        <p:nvSpPr>
+          <p:cNvPr id="5" name="TextBox 4"/>
+          <p:cNvSpPr txBox="1"/>
+          <p:nvPr/>
+        </p:nvSpPr>
+        <p:spPr>
+          <a:xfrm>
+            <a:off x="548640" y="6446520"/>
+            <a:ext cx="11064240" cy="320040"/>
+          </a:xfrm>
+          <a:prstGeom prst="rect">
+            <a:avLst/>
+          </a:prstGeom>
+          <a:noFill/>
+        </p:spPr>
+        <p:txBody>
+          <a:bodyPr wrap="square" tIns="0">
+            <a:spAutoFit/>
+          </a:bodyPr>
+          <a:lstStyle/>
+          <a:p>
+            <a:pPr>
+              <a:spcAft>
+                <a:spcPts val="600"/>
+              </a:spcAft>
+              <a:defRPr sz="900" b="0">
+                <a:solidFill>
+                  <a:srgbClr val="5A5A5A"/>
+                </a:solidFill>
+              </a:defRPr>
+            </a:pPr>
+            <a:r>
+              <a:t>Each dot is one region-week of simulated delivery, placed on the true response curve it was generated from.</a:t>
+            </a:r>
+          </a:p>
+        </p:txBody>
+      </p:sp>
+    </p:spTree>
+  </p:cSld>
+  <p:clrMapOvr>
+    <a:masterClrMapping/>
+  </p:clrMapOvr>
+</p:sld>
+</file>
+
+<file path=ppt/slides/slide7.xml><?xml version="1.0" encoding="utf-8"?>
+<p:sld xmlns:a="http://schemas.openxmlformats.org/drawingml/2006/main" xmlns:p="http://schemas.openxmlformats.org/presentationml/2006/main" xmlns:r="http://schemas.openxmlformats.org/officeDocument/2006/relationships">
+  <p:cSld>
+    <p:spTree>
+      <p:nvGrpSpPr>
+        <p:cNvPr id="1" name=""/>
+        <p:cNvGrpSpPr/>
+        <p:nvPr/>
+      </p:nvGrpSpPr>
+      <p:grpSpPr/>
+      <p:sp>
+        <p:nvSpPr>
+          <p:cNvPr id="2" name="TextBox 1"/>
+          <p:cNvSpPr txBox="1"/>
+          <p:nvPr/>
+        </p:nvSpPr>
+        <p:spPr>
+          <a:xfrm>
+            <a:off x="548640" y="320040"/>
+            <a:ext cx="11064240" cy="914400"/>
+          </a:xfrm>
+          <a:prstGeom prst="rect">
+            <a:avLst/>
+          </a:prstGeom>
+          <a:noFill/>
+        </p:spPr>
+        <p:txBody>
+          <a:bodyPr wrap="square" tIns="0">
+            <a:spAutoFit/>
+          </a:bodyPr>
+          <a:lstStyle/>
+          <a:p>
+            <a:pPr>
+              <a:spcAft>
+                <a:spcPts val="200"/>
+              </a:spcAft>
+              <a:defRPr sz="3000" b="1">
+                <a:solidFill>
+                  <a:srgbClr val="1A1A1A"/>
+                </a:solidFill>
+              </a:defRPr>
+            </a:pPr>
+            <a:r>
+              <a:t>Does the model recover the truth it was built from?</a:t>
+            </a:r>
+          </a:p>
+          <a:p>
+            <a:pPr>
+              <a:spcAft>
+                <a:spcPts val="600"/>
+              </a:spcAft>
+              <a:defRPr sz="1500" b="0">
+                <a:solidFill>
+                  <a:srgbClr val="5A5A5A"/>
+                </a:solidFill>
+              </a:defRPr>
+            </a:pPr>
+            <a:r>
+              <a:t>Same data, same model, same settings. The only difference between the two boxes in each panel is the saturation prior.</a:t>
+            </a:r>
+          </a:p>
+        </p:txBody>
+      </p:sp>
+      <p:pic>
+        <p:nvPicPr>
+          <p:cNvPr id="3" name="Picture 2" descr="slide7_recovery_boxplot_r90_fulldraws.png"/>
+          <p:cNvPicPr>
+            <a:picLocks noChangeAspect="1"/>
+          </p:cNvPicPr>
+          <p:nvPr/>
+        </p:nvPicPr>
+        <p:blipFill>
+          <a:blip r:embed="rId2"/>
+          <a:stretch>
+            <a:fillRect/>
+          </a:stretch>
+        </p:blipFill>
+        <p:spPr>
+          <a:xfrm>
+            <a:off x="910187" y="1417320"/>
+            <a:ext cx="10371321" cy="3931920"/>
+          </a:xfrm>
+          <a:prstGeom prst="rect">
+            <a:avLst/>
+          </a:prstGeom>
+        </p:spPr>
+      </p:pic>
+      <p:sp>
+        <p:nvSpPr>
+          <p:cNvPr id="4" name="TextBox 3"/>
+          <p:cNvSpPr txBox="1"/>
+          <p:nvPr/>
+        </p:nvSpPr>
+        <p:spPr>
+          <a:xfrm>
+            <a:off x="548640" y="5349240"/>
+            <a:ext cx="11064240" cy="1097280"/>
+          </a:xfrm>
+          <a:prstGeom prst="rect">
+            <a:avLst/>
+          </a:prstGeom>
+          <a:noFill/>
+        </p:spPr>
+        <p:txBody>
+          <a:bodyPr wrap="square" tIns="0">
+            <a:spAutoFit/>
+          </a:bodyPr>
+          <a:lstStyle/>
+          <a:p>
+            <a:pPr>
+              <a:spcAft>
+                <a:spcPts val="600"/>
+              </a:spcAft>
+              <a:defRPr sz="1400" b="1">
+                <a:solidFill>
+                  <a:srgbClr val="C0392B"/>
+                </a:solidFill>
+              </a:defRPr>
+            </a:pPr>
+            <a:r>
+              <a:t>The same default prior misses Channel-1’s saturation point by -69% and Channel-2’s by +5%. The error tracks how far the truth sits from the prior — not which channel it is.</a:t>
+            </a:r>
+          </a:p>
+          <a:p>
+            <a:pPr>
+              <a:spcAft>
+                <a:spcPts val="600"/>
+              </a:spcAft>
+              <a:defRPr sz="1300" b="0">
+                <a:solidFill>
+                  <a:srgbClr val="2C7FB8"/>
+                </a:solidFill>
+              </a:defRPr>
+            </a:pPr>
+            <a:r>
+              <a:t>A reach-informed prior — built from ordinary planning inputs and ~25% wrong — removes that bias (-4% median) and wins on 10/10 datasets, though it is far noisier on any single one. ROI improves (+44% → +21%) without being fixed; carryover is unchanged either way.</a:t>
+            </a:r>
+          </a:p>
+        </p:txBody>
+      </p:sp>
+      <p:sp>
+        <p:nvSpPr>
+          <p:cNvPr id="5" name="TextBox 4"/>
+          <p:cNvSpPr txBox="1"/>
+          <p:nvPr/>
+        </p:nvSpPr>
+        <p:spPr>
+          <a:xfrm>
+            <a:off x="548640" y="6446520"/>
+            <a:ext cx="11064240" cy="320040"/>
+          </a:xfrm>
+          <a:prstGeom prst="rect">
+            <a:avLst/>
+          </a:prstGeom>
+          <a:noFill/>
+        </p:spPr>
+        <p:txBody>
+          <a:bodyPr wrap="square" tIns="0">
+            <a:spAutoFit/>
+          </a:bodyPr>
+          <a:lstStyle/>
+          <a:p>
+            <a:pPr>
+              <a:spcAft>
+                <a:spcPts val="600"/>
+              </a:spcAft>
+              <a:defRPr sz="900" b="0">
+                <a:solidFill>
+                  <a:srgbClr val="5A5A5A"/>
+                </a:solidFill>
+              </a:defRPr>
+            </a:pPr>
+            <a:r>
+              <a:t>10 simulated datasets with IDENTICAL true parameters — only the noise differs, so seed-to-seed spread is noise and nothing else. Posterior draws pooled across seeds and chains (20000 per box); box widths show combined spread, not one model’s calibrated credible interval. The informed prior’s anchors are perturbed ~25% per dataset rather than set to the truth — an oracle prior would be unbiased by construction. oracle_r2 = 0.9.</a:t>
+            </a:r>
+          </a:p>
+        </p:txBody>
+      </p:sp>
+    </p:spTree>
+  </p:cSld>
+  <p:clrMapOvr>
+    <a:masterClrMapping/>
+  </p:clrMapOvr>
+</p:sld>
+</file>
+
+<file path=ppt/slides/slide8.xml><?xml version="1.0" encoding="utf-8"?>
+<p:sld xmlns:a="http://schemas.openxmlformats.org/drawingml/2006/main" xmlns:p="http://schemas.openxmlformats.org/presentationml/2006/main" xmlns:r="http://schemas.openxmlformats.org/officeDocument/2006/relationships">
+  <p:cSld>
+    <p:spTree>
+      <p:nvGrpSpPr>
+        <p:cNvPr id="1" name=""/>
+        <p:cNvGrpSpPr/>
+        <p:nvPr/>
+      </p:nvGrpSpPr>
+      <p:grpSpPr/>
+      <p:sp>
+        <p:nvSpPr>
+          <p:cNvPr id="2" name="TextBox 1"/>
+          <p:cNvSpPr txBox="1"/>
+          <p:nvPr/>
+        </p:nvSpPr>
+        <p:spPr>
+          <a:xfrm>
+            <a:off x="548640" y="320040"/>
+            <a:ext cx="11064240" cy="914400"/>
+          </a:xfrm>
+          <a:prstGeom prst="rect">
+            <a:avLst/>
+          </a:prstGeom>
+          <a:noFill/>
+        </p:spPr>
+        <p:txBody>
+          <a:bodyPr wrap="square" tIns="0">
+            <a:spAutoFit/>
+          </a:bodyPr>
+          <a:lstStyle/>
+          <a:p>
+            <a:pPr>
+              <a:spcAft>
+                <a:spcPts val="200"/>
+              </a:spcAft>
+              <a:defRPr sz="3000" b="1">
+                <a:solidFill>
+                  <a:srgbClr val="1A1A1A"/>
+                </a:solidFill>
+              </a:defRPr>
+            </a:pPr>
+            <a:r>
+              <a:t>So ask the model the question you actually bought it for</a:t>
+            </a:r>
+          </a:p>
+          <a:p>
+            <a:pPr>
+              <a:spcAft>
+                <a:spcPts val="600"/>
+              </a:spcAft>
+              <a:defRPr sz="1500" b="0">
+                <a:solidFill>
+                  <a:srgbClr val="5A5A5A"/>
+                </a:solidFill>
+              </a:defRPr>
+            </a:pPr>
+            <a:r>
+              <a:t>"Should I spend more here?" — marginal return at spend levels above today’s, across 10 datasets. Channel-2 is the control.</a:t>
+            </a:r>
+          </a:p>
+        </p:txBody>
+      </p:sp>
+      <p:pic>
+        <p:nvPicPr>
+          <p:cNvPr id="3" name="Picture 2" descr="slide8_mroi_r90_pinned.png"/>
+          <p:cNvPicPr>
+            <a:picLocks noChangeAspect="1"/>
+          </p:cNvPicPr>
+          <p:nvPr/>
+        </p:nvPicPr>
+        <p:blipFill>
+          <a:blip r:embed="rId2"/>
+          <a:stretch>
+            <a:fillRect/>
+          </a:stretch>
+        </p:blipFill>
+        <p:spPr>
+          <a:xfrm>
+            <a:off x="1311680" y="1371600"/>
+            <a:ext cx="9568334" cy="4206240"/>
+          </a:xfrm>
+          <a:prstGeom prst="rect">
+            <a:avLst/>
+          </a:prstGeom>
+        </p:spPr>
+      </p:pic>
+      <p:sp>
+        <p:nvSpPr>
+          <p:cNvPr id="4" name="TextBox 3"/>
+          <p:cNvSpPr txBox="1"/>
+          <p:nvPr/>
+        </p:nvSpPr>
+        <p:spPr>
+          <a:xfrm>
+            <a:off x="548640" y="5669280"/>
+            <a:ext cx="11064240" cy="914400"/>
+          </a:xfrm>
+          <a:prstGeom prst="rect">
+            <a:avLst/>
+          </a:prstGeom>
+          <a:noFill/>
+        </p:spPr>
+        <p:txBody>
+          <a:bodyPr wrap="square" tIns="0">
+            <a:spAutoFit/>
+          </a:bodyPr>
+          <a:lstStyle/>
+          <a:p>
+            <a:pPr>
+              <a:spcAft>
+                <a:spcPts val="600"/>
+              </a:spcAft>
+              <a:defRPr sz="1400" b="1">
+                <a:solidFill>
+                  <a:srgbClr val="C0392B"/>
+                </a:solidFill>
+              </a:defRPr>
+            </a:pPr>
+            <a:r>
+              <a:t>Same prior, same extrapolation to 10x: on Channel-1 the default is off -58%, on Channel-2 just -3%. The model does not break when you extrapolate — it breaks when you extrapolate from a misplaced saturation point.</a:t>
+            </a:r>
+          </a:p>
+          <a:p>
+            <a:pPr>
+              <a:spcAft>
+                <a:spcPts val="600"/>
+              </a:spcAft>
+              <a:defRPr sz="1300" b="0">
+                <a:solidFill>
+                  <a:srgbClr val="2C7FB8"/>
+                </a:solidFill>
+              </a:defRPr>
+            </a:pPr>
+            <a:r>
+              <a:t>On Channel-1 the default’s error also changes sign — +13% at today’s spend, -58% at 10x — flattering the channel today and starving it tomorrow. The reach-informed prior is biased but stably so, which is the property a reallocation needs.</a:t>
+            </a:r>
+          </a:p>
+        </p:txBody>
+      </p:sp>
+      <p:sp>
+        <p:nvSpPr>
+          <p:cNvPr id="5" name="TextBox 4"/>
+          <p:cNvSpPr txBox="1"/>
+          <p:nvPr/>
+        </p:nvSpPr>
+        <p:spPr>
+          <a:xfrm>
+            <a:off x="548640" y="6446520"/>
+            <a:ext cx="11064240" cy="320040"/>
+          </a:xfrm>
+          <a:prstGeom prst="rect">
+            <a:avLst/>
+          </a:prstGeom>
+          <a:noFill/>
+        </p:spPr>
+        <p:txBody>
+          <a:bodyPr wrap="square" tIns="0">
+            <a:spAutoFit/>
+          </a:bodyPr>
+          <a:lstStyle/>
+          <a:p>
+            <a:pPr>
+              <a:spcAft>
+                <a:spcPts val="600"/>
+              </a:spcAft>
+              <a:defRPr sz="900" b="0">
+                <a:solidFill>
+                  <a:srgbClr val="5A5A5A"/>
+                </a:solidFill>
+              </a:defRPr>
+            </a:pPr>
+            <a:r>
+              <a:t>10 datasets with identical true parameters; shaded band is the middle 50% of pooled draws, so it mixes posterior and between-seed spread rather than being one model’s calibrated interval. At a 90% interval the default contains the truth on 4/10 datasets at 1x and 0/10 at 10x for Channel-1, versus 7/10 for Channel-2. Y-axes differ by channel.</a:t>
+            </a:r>
+          </a:p>
+        </p:txBody>
+      </p:sp>
+    </p:spTree>
+  </p:cSld>
+  <p:clrMapOvr>
+    <a:masterClrMapping/>
+  </p:clrMapOvr>
+</p:sld>
+</file>
+
+<file path=ppt/slides/slide9.xml><?xml version="1.0" encoding="utf-8"?>
+<p:sld xmlns:a="http://schemas.openxmlformats.org/drawingml/2006/main" xmlns:p="http://schemas.openxmlformats.org/presentationml/2006/main" xmlns:r="http://schemas.openxmlformats.org/officeDocument/2006/relationships">
+  <p:cSld>
+    <p:spTree>
+      <p:nvGrpSpPr>
+        <p:cNvPr id="1" name=""/>
+        <p:cNvGrpSpPr/>
+        <p:nvPr/>
+      </p:nvGrpSpPr>
+      <p:grpSpPr/>
+      <p:sp>
+        <p:nvSpPr>
+          <p:cNvPr id="2" name="TextBox 1"/>
+          <p:cNvSpPr txBox="1"/>
+          <p:nvPr/>
+        </p:nvSpPr>
+        <p:spPr>
+          <a:xfrm>
+            <a:off x="548640" y="320040"/>
+            <a:ext cx="11064240" cy="914400"/>
+          </a:xfrm>
+          <a:prstGeom prst="rect">
+            <a:avLst/>
+          </a:prstGeom>
+          <a:noFill/>
+        </p:spPr>
+        <p:txBody>
+          <a:bodyPr wrap="square" tIns="0">
+            <a:spAutoFit/>
+          </a:bodyPr>
+          <a:lstStyle/>
+          <a:p>
+            <a:pPr>
+              <a:spcAft>
+                <a:spcPts val="200"/>
+              </a:spcAft>
+              <a:defRPr sz="3000" b="1">
+                <a:solidFill>
+                  <a:srgbClr val="1A1A1A"/>
+                </a:solidFill>
+              </a:defRPr>
+            </a:pPr>
+            <a:r>
+              <a:t>Key takeaways</a:t>
+            </a:r>
+          </a:p>
+          <a:p>
+            <a:pPr>
+              <a:spcAft>
+                <a:spcPts val="600"/>
+              </a:spcAft>
+              <a:defRPr sz="1500" b="0">
+                <a:solidFill>
+                  <a:srgbClr val="5A5A5A"/>
+                </a:solidFill>
+              </a:defRPr>
+            </a:pPr>
+            <a:r>
+              <a:t>The defaults are a starting point, not a measurement — and you are never asked to confirm them.</a:t>
+            </a:r>
+          </a:p>
+        </p:txBody>
+      </p:sp>
+      <p:sp>
+        <p:nvSpPr>
+          <p:cNvPr id="3" name="TextBox 2"/>
+          <p:cNvSpPr txBox="1"/>
+          <p:nvPr/>
+        </p:nvSpPr>
+        <p:spPr>
+          <a:xfrm>
+            <a:off x="640080" y="1600200"/>
+            <a:ext cx="5212080" cy="4480560"/>
+          </a:xfrm>
+          <a:prstGeom prst="rect">
+            <a:avLst/>
+          </a:prstGeom>
+          <a:noFill/>
+        </p:spPr>
+        <p:txBody>
+          <a:bodyPr wrap="square" tIns="0">
+            <a:spAutoFit/>
+          </a:bodyPr>
+          <a:lstStyle/>
+          <a:p>
+            <a:pPr>
+              <a:spcAft>
+                <a:spcPts val="1200"/>
+              </a:spcAft>
+              <a:defRPr sz="1300" b="1">
+                <a:solidFill>
+                  <a:srgbClr val="C0392B"/>
+                </a:solidFill>
+              </a:defRPr>
+            </a:pPr>
+            <a:r>
+              <a:t>WHAT THE TEN DATASETS SHOWED</a:t>
+            </a:r>
+          </a:p>
+          <a:p>
+            <a:pPr>
+              <a:spcAft>
+                <a:spcPts val="200"/>
+              </a:spcAft>
+              <a:defRPr sz="1400" b="1">
+                <a:solidFill>
+                  <a:srgbClr val="2C7FB8"/>
+                </a:solidFill>
+              </a:defRPr>
+            </a:pPr>
+            <a:r>
+              <a:t>1.  The saturation prior is the same for every channel.</a:t>
+            </a:r>
+          </a:p>
+          <a:p>
+            <a:pPr>
+              <a:spcAft>
+                <a:spcPts val="1400"/>
+              </a:spcAft>
+              <a:defRPr sz="1200" b="0">
+                <a:solidFill>
+                  <a:srgbClr val="5A5A5A"/>
+                </a:solidFill>
+              </a:defRPr>
+            </a:pPr>
+            <a:r>
+              <a:t>     It assumes you are already near the knee. On the under-reached channel it missed the truth by -69%.</a:t>
+            </a:r>
+          </a:p>
+          <a:p>
+            <a:pPr>
+              <a:spcAft>
+                <a:spcPts val="200"/>
+              </a:spcAft>
+              <a:defRPr sz="1400" b="1">
+                <a:solidFill>
+                  <a:srgbClr val="2C7FB8"/>
+                </a:solidFill>
+              </a:defRPr>
+            </a:pPr>
+            <a:r>
+              <a:t>2.  It only misleads where your channel sits far from it.</a:t>
+            </a:r>
+          </a:p>
+          <a:p>
+            <a:pPr>
+              <a:spcAft>
+                <a:spcPts val="1400"/>
+              </a:spcAft>
+              <a:defRPr sz="1200" b="0">
+                <a:solidFill>
+                  <a:srgbClr val="5A5A5A"/>
+                </a:solidFill>
+              </a:defRPr>
+            </a:pPr>
+            <a:r>
+              <a:t>     Same prior, same fit, same 10 datasets: the well-reached channel came back +5%. That is a prior problem, not a broken model.</a:t>
+            </a:r>
+          </a:p>
+          <a:p>
+            <a:pPr>
+              <a:spcAft>
+                <a:spcPts val="200"/>
+              </a:spcAft>
+              <a:defRPr sz="1400" b="1">
+                <a:solidFill>
+                  <a:srgbClr val="2C7FB8"/>
+                </a:solidFill>
+              </a:defRPr>
+            </a:pPr>
+            <a:r>
+              <a:t>3.  The error compounds as you extrapolate.</a:t>
+            </a:r>
+          </a:p>
+          <a:p>
+            <a:pPr>
+              <a:spcAft>
+                <a:spcPts val="1400"/>
+              </a:spcAft>
+              <a:defRPr sz="1200" b="0">
+                <a:solidFill>
+                  <a:srgbClr val="5A5A5A"/>
+                </a:solidFill>
+              </a:defRPr>
+            </a:pPr>
+            <a:r>
+              <a:t>     Marginal ROI ran +13% at today's spend to -58% at 10x, with the 90% interval missing the truth on 10/10 datasets.</a:t>
+            </a:r>
+          </a:p>
+        </p:txBody>
+      </p:sp>
+      <p:sp>
+        <p:nvSpPr>
+          <p:cNvPr id="4" name="TextBox 3"/>
+          <p:cNvSpPr txBox="1"/>
+          <p:nvPr/>
+        </p:nvSpPr>
+        <p:spPr>
+          <a:xfrm>
+            <a:off x="6309360" y="1600200"/>
+            <a:ext cx="5303520" cy="4480560"/>
+          </a:xfrm>
+          <a:prstGeom prst="rect">
+            <a:avLst/>
+          </a:prstGeom>
+          <a:noFill/>
+        </p:spPr>
+        <p:txBody>
+          <a:bodyPr wrap="square" tIns="0">
+            <a:spAutoFit/>
+          </a:bodyPr>
+          <a:lstStyle/>
+          <a:p>
+            <a:pPr>
+              <a:spcAft>
+                <a:spcPts val="1200"/>
+              </a:spcAft>
+              <a:defRPr sz="1300" b="1">
+                <a:solidFill>
+                  <a:srgbClr val="C0392B"/>
+                </a:solidFill>
+              </a:defRPr>
+            </a:pPr>
+            <a:r>
+              <a:t>WHAT TO CHANGE IN YOUR OWN MODEL</a:t>
+            </a:r>
+          </a:p>
+          <a:p>
+            <a:pPr>
+              <a:spcAft>
+                <a:spcPts val="200"/>
+              </a:spcAft>
+              <a:defRPr sz="1400" b="1">
+                <a:solidFill>
+                  <a:srgbClr val="2C7FB8"/>
+                </a:solidFill>
+              </a:defRPr>
+            </a:pPr>
+            <a:r>
+              <a:t>1.  Ask what your model assumes before it sees your data.</a:t>
+            </a:r>
+          </a:p>
+          <a:p>
+            <a:pPr>
+              <a:spcAft>
+                <a:spcPts val="1000"/>
+              </a:spcAft>
+              <a:defRPr sz="1200" b="0">
+                <a:solidFill>
+                  <a:srgbClr val="5A5A5A"/>
+                </a:solidFill>
+              </a:defRPr>
+            </a:pPr>
+            <a:r>
+              <a:t>     We did: the default gives 50% odds that every channel — whatever its audience or delivery — is already past half-saturation.</a:t>
+            </a:r>
+          </a:p>
+          <a:p>
+            <a:pPr>
+              <a:spcAft>
+                <a:spcPts val="200"/>
+              </a:spcAft>
+              <a:defRPr sz="1400" b="1">
+                <a:solidFill>
+                  <a:srgbClr val="2C7FB8"/>
+                </a:solidFill>
+              </a:defRPr>
+            </a:pPr>
+            <a:r>
+              <a:t>2.  Build the saturation prior from delivery.</a:t>
+            </a:r>
+          </a:p>
+          <a:p>
+            <a:pPr>
+              <a:spcAft>
+                <a:spcPts val="1000"/>
+              </a:spcAft>
+              <a:defRPr sz="1200" b="0">
+                <a:solidFill>
+                  <a:srgbClr val="5A5A5A"/>
+                </a:solidFill>
+              </a:defRPr>
+            </a:pPr>
+            <a:r>
+              <a:t>     What share of your addressable audience you reach, and how often. Audience size alone is not the input — it cancels; the shortfall against it is what moves the answer.</a:t>
+            </a:r>
+          </a:p>
+          <a:p>
+            <a:pPr>
+              <a:spcAft>
+                <a:spcPts val="200"/>
+              </a:spcAft>
+              <a:defRPr sz="1400" b="1">
+                <a:solidFill>
+                  <a:srgbClr val="2C7FB8"/>
+                </a:solidFill>
+              </a:defRPr>
+            </a:pPr>
+            <a:r>
+              <a:t>3.  Set the carryover window deliberately.</a:t>
+            </a:r>
+          </a:p>
+          <a:p>
+            <a:pPr>
+              <a:spcAft>
+                <a:spcPts val="1000"/>
+              </a:spcAft>
+              <a:defRPr sz="1200" b="0">
+                <a:solidFill>
+                  <a:srgbClr val="5A5A5A"/>
+                </a:solidFill>
+              </a:defRPr>
+            </a:pPr>
+            <a:r>
+              <a:t>     max_lag is a hard truncation, not a prior, and it moved our results. The decay prior alone did not: +17% vs +15%, indistinguishable.</a:t>
+            </a:r>
+          </a:p>
+          <a:p>
+            <a:pPr>
+              <a:spcAft>
+                <a:spcPts val="200"/>
+              </a:spcAft>
+              <a:defRPr sz="1400" b="1">
+                <a:solidFill>
+                  <a:srgbClr val="2C7FB8"/>
+                </a:solidFill>
+              </a:defRPr>
+            </a:pPr>
+            <a:r>
+              <a:t>4.  Stress-test at 2–5x spend, not at today's.</a:t>
+            </a:r>
+          </a:p>
+          <a:p>
+            <a:pPr>
+              <a:spcAft>
+                <a:spcPts val="1000"/>
+              </a:spcAft>
+              <a:defRPr sz="1200" b="0">
+                <a:solidFill>
+                  <a:srgbClr val="5A5A5A"/>
+                </a:solidFill>
+              </a:defRPr>
+            </a:pPr>
+            <a:r>
+              <a:t>     ROI and marginal ROI at current spend both concealed this. Only the elevated-spend curve separated the two priors.</a:t>
+            </a:r>
+          </a:p>
+        </p:txBody>
+      </p:sp>
+      <p:sp>
+        <p:nvSpPr>
+          <p:cNvPr id="5" name="TextBox 4"/>
+          <p:cNvSpPr txBox="1"/>
+          <p:nvPr/>
+        </p:nvSpPr>
+        <p:spPr>
+          <a:xfrm>
+            <a:off x="548640" y="6446520"/>
+            <a:ext cx="11064240" cy="320040"/>
+          </a:xfrm>
+          <a:prstGeom prst="rect">
+            <a:avLst/>
+          </a:prstGeom>
+          <a:noFill/>
+        </p:spPr>
+        <p:txBody>
+          <a:bodyPr wrap="square" tIns="0">
+            <a:spAutoFit/>
+          </a:bodyPr>
+          <a:lstStyle/>
+          <a:p>
+            <a:pPr>
+              <a:spcAft>
+                <a:spcPts val="600"/>
+              </a:spcAft>
+              <a:defRPr sz="900" b="0">
+                <a:solidFill>
+                  <a:srgbClr val="5A5A5A"/>
+                </a:solidFill>
+              </a:defRPr>
+            </a:pPr>
+            <a:r>
+              <a:t>An informed prior removes the systematic bias; it does not recover the parameter. Its anchors were perturbed ~25% per dataset and it won 10/10, but it is wide on any single one (-31% to +27% interquartile) — its accuracy is inherited from your planning inputs, not estimated from the data.</a:t>
             </a:r>
           </a:p>
         </p:txBody>
@@ -4877,324 +5698,4 @@
   </a:objectDefaults>
   <a:extraClrSchemeLst/>
 </a:theme>
-</file>
-
-<file path=ppt/theme/theme2.xml><?xml version="1.0" encoding="utf-8"?>
-<a:theme xmlns:a="http://schemas.openxmlformats.org/drawingml/2006/main" name="Office Theme">
-  <a:themeElements>
-    <a:clrScheme name="Office">
-      <a:dk1>
-        <a:sysClr val="windowText" lastClr="000000"/>
-      </a:dk1>
-      <a:lt1>
-        <a:sysClr val="window" lastClr="FFFFFF"/>
-      </a:lt1>
-      <a:dk2>
-        <a:srgbClr val="1F497D"/>
-      </a:dk2>
-      <a:lt2>
-        <a:srgbClr val="EEECE1"/>
-      </a:lt2>
-      <a:accent1>
-        <a:srgbClr val="4F81BD"/>
-      </a:accent1>
-      <a:accent2>
-        <a:srgbClr val="C0504D"/>
-      </a:accent2>
-      <a:accent3>
-        <a:srgbClr val="9BBB59"/>
-      </a:accent3>
-      <a:accent4>
-        <a:srgbClr val="8064A2"/>
-      </a:accent4>
-      <a:accent5>
-        <a:srgbClr val="4BACC6"/>
-      </a:accent5>
-      <a:accent6>
-        <a:srgbClr val="F79646"/>
-      </a:accent6>
-      <a:hlink>
-        <a:srgbClr val="0000FF"/>
-      </a:hlink>
-      <a:folHlink>
-        <a:srgbClr val="800080"/>
-      </a:folHlink>
-    </a:clrScheme>
-    <a:fontScheme name="Office">
-      <a:majorFont>
-        <a:latin typeface="Calibri"/>
-        <a:ea typeface=""/>
-        <a:cs typeface=""/>
-        <a:font script="Jpan" typeface="ＭＳ Ｐゴシック"/>
-        <a:font script="Hang" typeface="맑은 고딕"/>
-        <a:font script="Hans" typeface="宋体"/>
-        <a:font script="Hant" typeface="新細明體"/>
-        <a:font script="Arab" typeface="Times New Roman"/>
-        <a:font script="Hebr" typeface="Times New Roman"/>
-        <a:font script="Thai" typeface="Angsana New"/>
-        <a:font script="Ethi" typeface="Nyala"/>
-        <a:font script="Beng" typeface="Vrinda"/>
-        <a:font script="Gujr" typeface="Shruti"/>
-        <a:font script="Khmr" typeface="MoolBoran"/>
-        <a:font script="Knda" typeface="Tunga"/>
-        <a:font script="Guru" typeface="Raavi"/>
-        <a:font script="Cans" typeface="Euphemia"/>
-        <a:font script="Cher" typeface="Plantagenet Cherokee"/>
-        <a:font script="Yiii" typeface="Microsoft Yi Baiti"/>
-        <a:font script="Tibt" typeface="Microsoft Himalaya"/>
-        <a:font script="Thaa" typeface="MV Boli"/>
-        <a:font script="Deva" typeface="Mangal"/>
-        <a:font script="Telu" typeface="Gautami"/>
-        <a:font script="Taml" typeface="Latha"/>
-        <a:font script="Syrc" typeface="Estrangelo Edessa"/>
-        <a:font script="Orya" typeface="Kalinga"/>
-        <a:font script="Mlym" typeface="Kartika"/>
-        <a:font script="Laoo" typeface="DokChampa"/>
-        <a:font script="Sinh" typeface="Iskoola Pota"/>
-        <a:font script="Mong" typeface="Mongolian Baiti"/>
-        <a:font script="Viet" typeface="Times New Roman"/>
-        <a:font script="Uigh" typeface="Microsoft Uighur"/>
-        <a:font script="Geor" typeface="Sylfaen"/>
-      </a:majorFont>
-      <a:minorFont>
-        <a:latin typeface="Calibri"/>
-        <a:ea typeface=""/>
-        <a:cs typeface=""/>
-        <a:font script="Jpan" typeface="ＭＳ Ｐゴシック"/>
-        <a:font script="Hang" typeface="맑은 고딕"/>
-        <a:font script="Hans" typeface="宋体"/>
-        <a:font script="Hant" typeface="新細明體"/>
-        <a:font script="Arab" typeface="Arial"/>
-        <a:font script="Hebr" typeface="Arial"/>
-        <a:font script="Thai" typeface="Cordia New"/>
-        <a:font script="Ethi" typeface="Nyala"/>
-        <a:font script="Beng" typeface="Vrinda"/>
-        <a:font script="Gujr" typeface="Shruti"/>
-        <a:font script="Khmr" typeface="DaunPenh"/>
-        <a:font script="Knda" typeface="Tunga"/>
-        <a:font script="Guru" typeface="Raavi"/>
-        <a:font script="Cans" typeface="Euphemia"/>
-        <a:font script="Cher" typeface="Plantagenet Cherokee"/>
-        <a:font script="Yiii" typeface="Microsoft Yi Baiti"/>
-        <a:font script="Tibt" typeface="Microsoft Himalaya"/>
-        <a:font script="Thaa" typeface="MV Boli"/>
-        <a:font script="Deva" typeface="Mangal"/>
-        <a:font script="Telu" typeface="Gautami"/>
-        <a:font script="Taml" typeface="Latha"/>
-        <a:font script="Syrc" typeface="Estrangelo Edessa"/>
-        <a:font script="Orya" typeface="Kalinga"/>
-        <a:font script="Mlym" typeface="Kartika"/>
-        <a:font script="Laoo" typeface="DokChampa"/>
-        <a:font script="Sinh" typeface="Iskoola Pota"/>
-        <a:font script="Mong" typeface="Mongolian Baiti"/>
-        <a:font script="Viet" typeface="Arial"/>
-        <a:font script="Uigh" typeface="Microsoft Uighur"/>
-        <a:font script="Geor" typeface="Sylfaen"/>
-      </a:minorFont>
-    </a:fontScheme>
-    <a:fmtScheme name="Office">
-      <a:fillStyleLst>
-        <a:solidFill>
-          <a:schemeClr val="phClr"/>
-        </a:solidFill>
-        <a:gradFill rotWithShape="1">
-          <a:gsLst>
-            <a:gs pos="0">
-              <a:schemeClr val="phClr">
-                <a:tint val="50000"/>
-                <a:satMod val="300000"/>
-              </a:schemeClr>
-            </a:gs>
-            <a:gs pos="35000">
-              <a:schemeClr val="phClr">
-                <a:tint val="37000"/>
-                <a:satMod val="300000"/>
-              </a:schemeClr>
-            </a:gs>
-            <a:gs pos="100000">
-              <a:schemeClr val="phClr">
-                <a:tint val="15000"/>
-                <a:satMod val="350000"/>
-              </a:schemeClr>
-            </a:gs>
-          </a:gsLst>
-          <a:lin ang="16200000" scaled="1"/>
-        </a:gradFill>
-        <a:gradFill rotWithShape="1">
-          <a:gsLst>
-            <a:gs pos="0">
-              <a:schemeClr val="phClr">
-                <a:tint val="100000"/>
-                <a:shade val="100000"/>
-                <a:satMod val="130000"/>
-              </a:schemeClr>
-            </a:gs>
-            <a:gs pos="100000">
-              <a:schemeClr val="phClr">
-                <a:tint val="50000"/>
-                <a:shade val="100000"/>
-                <a:satMod val="350000"/>
-              </a:schemeClr>
-            </a:gs>
-          </a:gsLst>
-          <a:lin ang="16200000" scaled="0"/>
-        </a:gradFill>
-      </a:fillStyleLst>
-      <a:lnStyleLst>
-        <a:ln w="9525" cap="flat" cmpd="sng" algn="ctr">
-          <a:solidFill>
-            <a:schemeClr val="phClr">
-              <a:shade val="95000"/>
-              <a:satMod val="105000"/>
-            </a:schemeClr>
-          </a:solidFill>
-          <a:prstDash val="solid"/>
-        </a:ln>
-        <a:ln w="25400" cap="flat" cmpd="sng" algn="ctr">
-          <a:solidFill>
-            <a:schemeClr val="phClr"/>
-          </a:solidFill>
-          <a:prstDash val="solid"/>
-        </a:ln>
-        <a:ln w="38100" cap="flat" cmpd="sng" algn="ctr">
-          <a:solidFill>
-            <a:schemeClr val="phClr"/>
-          </a:solidFill>
-          <a:prstDash val="solid"/>
-        </a:ln>
-      </a:lnStyleLst>
-      <a:effectStyleLst>
-        <a:effectStyle>
-          <a:effectLst>
-            <a:outerShdw blurRad="40000" dist="20000" dir="5400000" rotWithShape="0">
-              <a:srgbClr val="000000">
-                <a:alpha val="38000"/>
-              </a:srgbClr>
-            </a:outerShdw>
-          </a:effectLst>
-        </a:effectStyle>
-        <a:effectStyle>
-          <a:effectLst>
-            <a:outerShdw blurRad="40000" dist="23000" dir="5400000" rotWithShape="0">
-              <a:srgbClr val="000000">
-                <a:alpha val="35000"/>
-              </a:srgbClr>
-            </a:outerShdw>
-          </a:effectLst>
-        </a:effectStyle>
-        <a:effectStyle>
-          <a:effectLst>
-            <a:outerShdw blurRad="40000" dist="23000" dir="5400000" rotWithShape="0">
-              <a:srgbClr val="000000">
-                <a:alpha val="35000"/>
-              </a:srgbClr>
-            </a:outerShdw>
-          </a:effectLst>
-          <a:scene3d>
-            <a:camera prst="orthographicFront">
-              <a:rot lat="0" lon="0" rev="0"/>
-            </a:camera>
-            <a:lightRig rig="threePt" dir="t">
-              <a:rot lat="0" lon="0" rev="1200000"/>
-            </a:lightRig>
-          </a:scene3d>
-          <a:sp3d>
-            <a:bevelT w="63500" h="25400"/>
-          </a:sp3d>
-        </a:effectStyle>
-      </a:effectStyleLst>
-      <a:bgFillStyleLst>
-        <a:solidFill>
-          <a:schemeClr val="phClr"/>
-        </a:solidFill>
-        <a:gradFill rotWithShape="1">
-          <a:gsLst>
-            <a:gs pos="0">
-              <a:schemeClr val="phClr">
-                <a:tint val="40000"/>
-                <a:satMod val="350000"/>
-              </a:schemeClr>
-            </a:gs>
-            <a:gs pos="40000">
-              <a:schemeClr val="phClr">
-                <a:tint val="45000"/>
-                <a:shade val="99000"/>
-                <a:satMod val="350000"/>
-              </a:schemeClr>
-            </a:gs>
-            <a:gs pos="100000">
-              <a:schemeClr val="phClr">
-                <a:shade val="20000"/>
-                <a:satMod val="255000"/>
-              </a:schemeClr>
-            </a:gs>
-          </a:gsLst>
-          <a:path path="circle">
-            <a:fillToRect l="50000" t="-80000" r="50000" b="180000"/>
-          </a:path>
-        </a:gradFill>
-        <a:gradFill rotWithShape="1">
-          <a:gsLst>
-            <a:gs pos="0">
-              <a:schemeClr val="phClr">
-                <a:tint val="80000"/>
-                <a:satMod val="300000"/>
-              </a:schemeClr>
-            </a:gs>
-            <a:gs pos="100000">
-              <a:schemeClr val="phClr">
-                <a:shade val="30000"/>
-                <a:satMod val="200000"/>
-              </a:schemeClr>
-            </a:gs>
-          </a:gsLst>
-          <a:path path="circle">
-            <a:fillToRect l="50000" t="50000" r="50000" b="50000"/>
-          </a:path>
-        </a:gradFill>
-      </a:bgFillStyleLst>
-    </a:fmtScheme>
-  </a:themeElements>
-  <a:objectDefaults>
-    <a:spDef>
-      <a:spPr/>
-      <a:bodyPr/>
-      <a:lstStyle/>
-      <a:style>
-        <a:lnRef idx="1">
-          <a:schemeClr val="accent1"/>
-        </a:lnRef>
-        <a:fillRef idx="3">
-          <a:schemeClr val="accent1"/>
-        </a:fillRef>
-        <a:effectRef idx="2">
-          <a:schemeClr val="accent1"/>
-        </a:effectRef>
-        <a:fontRef idx="minor">
-          <a:schemeClr val="lt1"/>
-        </a:fontRef>
-      </a:style>
-    </a:spDef>
-    <a:lnDef>
-      <a:spPr/>
-      <a:bodyPr/>
-      <a:lstStyle/>
-      <a:style>
-        <a:lnRef idx="2">
-          <a:schemeClr val="accent1"/>
-        </a:lnRef>
-        <a:fillRef idx="0">
-          <a:schemeClr val="accent1"/>
-        </a:fillRef>
-        <a:effectRef idx="1">
-          <a:schemeClr val="accent1"/>
-        </a:effectRef>
-        <a:fontRef idx="minor">
-          <a:schemeClr val="tx1"/>
-        </a:fontRef>
-      </a:style>
-    </a:lnDef>
-  </a:objectDefaults>
-  <a:extraClrSchemeLst/>
-</a:theme>
 </file>
</xml_diff>